<commit_message>
feat: embed architecture diagram PNG into technical PPTX slide 12
</commit_message>
<xml_diff>
--- a/presentations/technical/technical_presentation.pptx
+++ b/presentations/technical/technical_presentation.pptx
@@ -5698,49 +5698,30 @@
           </a:p>
         </p:txBody>
       </p:sp>
-      <p:sp>
-        <p:nvSpPr>
-          <p:cNvPr id="5" name="Rectangle 4"/>
-          <p:cNvSpPr/>
-          <p:nvPr/>
-        </p:nvSpPr>
-        <p:spPr>
-          <a:xfrm>
-            <a:off x="365760" y="1234440"/>
-            <a:ext cx="6400800" cy="4114800"/>
-          </a:xfrm>
-          <a:prstGeom prst="rect">
-            <a:avLst/>
-          </a:prstGeom>
-          <a:solidFill>
-            <a:srgbClr val="10101A"/>
-          </a:solidFill>
-          <a:ln>
-            <a:noFill/>
-          </a:ln>
-        </p:spPr>
-        <p:style>
-          <a:lnRef idx="1">
-            <a:schemeClr val="accent1"/>
-          </a:lnRef>
-          <a:fillRef idx="3">
-            <a:schemeClr val="accent1"/>
-          </a:fillRef>
-          <a:effectRef idx="2">
-            <a:schemeClr val="accent1"/>
-          </a:effectRef>
-          <a:fontRef idx="minor">
-            <a:schemeClr val="lt1"/>
-          </a:fontRef>
-        </p:style>
-        <p:txBody>
-          <a:bodyPr rtlCol="0" anchor="ctr"/>
-          <a:lstStyle/>
-          <a:p>
-            <a:pPr algn="ctr"/>
-          </a:p>
-        </p:txBody>
-      </p:sp>
+      <p:pic>
+        <p:nvPicPr>
+          <p:cNvPr id="5" name="Picture 4" descr="architecture_diagram.png"/>
+          <p:cNvPicPr>
+            <a:picLocks noChangeAspect="1"/>
+          </p:cNvPicPr>
+          <p:nvPr/>
+        </p:nvPicPr>
+        <p:blipFill>
+          <a:blip r:embed="rId2"/>
+          <a:stretch>
+            <a:fillRect/>
+          </a:stretch>
+        </p:blipFill>
+        <p:spPr>
+          <a:xfrm>
+            <a:off x="274320" y="1188720"/>
+            <a:ext cx="7132320" cy="4279392"/>
+          </a:xfrm>
+          <a:prstGeom prst="rect">
+            <a:avLst/>
+          </a:prstGeom>
+        </p:spPr>
+      </p:pic>
       <p:sp>
         <p:nvSpPr>
           <p:cNvPr id="6" name="TextBox 5"/>
@@ -5749,8 +5730,8 @@
         </p:nvSpPr>
         <p:spPr>
           <a:xfrm>
-            <a:off x="457200" y="1325880"/>
-            <a:ext cx="6217920" cy="457200"/>
+            <a:off x="7589520" y="1234440"/>
+            <a:ext cx="4389120" cy="384048"/>
           </a:xfrm>
           <a:prstGeom prst="rect">
             <a:avLst/>
@@ -5765,244 +5746,6 @@
           <a:p>
             <a:pPr algn="l"/>
             <a:r>
-              <a:rPr sz="1300" b="0" i="0">
-                <a:solidFill>
-                  <a:srgbClr val="CCCCCC"/>
-                </a:solidFill>
-              </a:rPr>
-              <a:t>Client Request</a:t>
-            </a:r>
-          </a:p>
-        </p:txBody>
-      </p:sp>
-      <p:sp>
-        <p:nvSpPr>
-          <p:cNvPr id="7" name="TextBox 6"/>
-          <p:cNvSpPr txBox="1"/>
-          <p:nvPr/>
-        </p:nvSpPr>
-        <p:spPr>
-          <a:xfrm>
-            <a:off x="457200" y="1828800"/>
-            <a:ext cx="6217920" cy="457200"/>
-          </a:xfrm>
-          <a:prstGeom prst="rect">
-            <a:avLst/>
-          </a:prstGeom>
-          <a:noFill/>
-        </p:spPr>
-        <p:txBody>
-          <a:bodyPr wrap="square">
-            <a:spAutoFit/>
-          </a:bodyPr>
-          <a:lstStyle/>
-          <a:p>
-            <a:pPr algn="l"/>
-            <a:r>
-              <a:rPr sz="1300" b="0" i="0">
-                <a:solidFill>
-                  <a:srgbClr val="FFFFFF"/>
-                </a:solidFill>
-              </a:rPr>
-              <a:t>POST /predict  →  FastAPI  (app.py)</a:t>
-            </a:r>
-          </a:p>
-        </p:txBody>
-      </p:sp>
-      <p:sp>
-        <p:nvSpPr>
-          <p:cNvPr id="8" name="TextBox 7"/>
-          <p:cNvSpPr txBox="1"/>
-          <p:nvPr/>
-        </p:nvSpPr>
-        <p:spPr>
-          <a:xfrm>
-            <a:off x="457200" y="2331720"/>
-            <a:ext cx="6217920" cy="457200"/>
-          </a:xfrm>
-          <a:prstGeom prst="rect">
-            <a:avLst/>
-          </a:prstGeom>
-          <a:noFill/>
-        </p:spPr>
-        <p:txBody>
-          <a:bodyPr wrap="square">
-            <a:spAutoFit/>
-          </a:bodyPr>
-          <a:lstStyle/>
-          <a:p>
-            <a:pPr algn="l"/>
-            <a:r>
-              <a:rPr sz="1300" b="0" i="0">
-                <a:solidFill>
-                  <a:srgbClr val="CCCCCC"/>
-                </a:solidFill>
-              </a:rPr>
-              <a:t>  │  Pydantic validation  (41 features, range checks)</a:t>
-            </a:r>
-          </a:p>
-        </p:txBody>
-      </p:sp>
-      <p:sp>
-        <p:nvSpPr>
-          <p:cNvPr id="9" name="TextBox 8"/>
-          <p:cNvSpPr txBox="1"/>
-          <p:nvPr/>
-        </p:nvSpPr>
-        <p:spPr>
-          <a:xfrm>
-            <a:off x="457200" y="2834640"/>
-            <a:ext cx="6217920" cy="457200"/>
-          </a:xfrm>
-          <a:prstGeom prst="rect">
-            <a:avLst/>
-          </a:prstGeom>
-          <a:noFill/>
-        </p:spPr>
-        <p:txBody>
-          <a:bodyPr wrap="square">
-            <a:spAutoFit/>
-          </a:bodyPr>
-          <a:lstStyle/>
-          <a:p>
-            <a:pPr algn="l"/>
-            <a:r>
-              <a:rPr sz="1300" b="0" i="0">
-                <a:solidFill>
-                  <a:srgbClr val="CCCCCC"/>
-                </a:solidFill>
-              </a:rPr>
-              <a:t>  │  X-From header enforcement  (traceability)</a:t>
-            </a:r>
-          </a:p>
-        </p:txBody>
-      </p:sp>
-      <p:sp>
-        <p:nvSpPr>
-          <p:cNvPr id="10" name="TextBox 9"/>
-          <p:cNvSpPr txBox="1"/>
-          <p:nvPr/>
-        </p:nvSpPr>
-        <p:spPr>
-          <a:xfrm>
-            <a:off x="457200" y="3337560"/>
-            <a:ext cx="6217920" cy="457200"/>
-          </a:xfrm>
-          <a:prstGeom prst="rect">
-            <a:avLst/>
-          </a:prstGeom>
-          <a:noFill/>
-        </p:spPr>
-        <p:txBody>
-          <a:bodyPr wrap="square">
-            <a:spAutoFit/>
-          </a:bodyPr>
-          <a:lstStyle/>
-          <a:p>
-            <a:pPr algn="l"/>
-            <a:r>
-              <a:rPr sz="1300" b="0" i="0">
-                <a:solidFill>
-                  <a:srgbClr val="CCCCCC"/>
-                </a:solidFill>
-              </a:rPr>
-              <a:t>  │  preprocessor.pkl  →  ColumnTransformer</a:t>
-            </a:r>
-          </a:p>
-        </p:txBody>
-      </p:sp>
-      <p:sp>
-        <p:nvSpPr>
-          <p:cNvPr id="11" name="TextBox 10"/>
-          <p:cNvSpPr txBox="1"/>
-          <p:nvPr/>
-        </p:nvSpPr>
-        <p:spPr>
-          <a:xfrm>
-            <a:off x="457200" y="3840480"/>
-            <a:ext cx="6217920" cy="457200"/>
-          </a:xfrm>
-          <a:prstGeom prst="rect">
-            <a:avLst/>
-          </a:prstGeom>
-          <a:noFill/>
-        </p:spPr>
-        <p:txBody>
-          <a:bodyPr wrap="square">
-            <a:spAutoFit/>
-          </a:bodyPr>
-          <a:lstStyle/>
-          <a:p>
-            <a:pPr algn="l"/>
-            <a:r>
-              <a:rPr sz="1300" b="0" i="0">
-                <a:solidFill>
-                  <a:srgbClr val="CCCCCC"/>
-                </a:solidFill>
-              </a:rPr>
-              <a:t>  │  xgboost.pkl  →  predict_proba()</a:t>
-            </a:r>
-          </a:p>
-        </p:txBody>
-      </p:sp>
-      <p:sp>
-        <p:nvSpPr>
-          <p:cNvPr id="12" name="TextBox 11"/>
-          <p:cNvSpPr txBox="1"/>
-          <p:nvPr/>
-        </p:nvSpPr>
-        <p:spPr>
-          <a:xfrm>
-            <a:off x="457200" y="4343400"/>
-            <a:ext cx="6217920" cy="457200"/>
-          </a:xfrm>
-          <a:prstGeom prst="rect">
-            <a:avLst/>
-          </a:prstGeom>
-          <a:noFill/>
-        </p:spPr>
-        <p:txBody>
-          <a:bodyPr wrap="square">
-            <a:spAutoFit/>
-          </a:bodyPr>
-          <a:lstStyle/>
-          <a:p>
-            <a:pPr algn="l"/>
-            <a:r>
-              <a:rPr sz="1300" b="0" i="0">
-                <a:solidFill>
-                  <a:srgbClr val="F5A623"/>
-                </a:solidFill>
-              </a:rPr>
-              <a:t>  └─ Response:  { prediction, label, probability }</a:t>
-            </a:r>
-          </a:p>
-        </p:txBody>
-      </p:sp>
-      <p:sp>
-        <p:nvSpPr>
-          <p:cNvPr id="13" name="TextBox 12"/>
-          <p:cNvSpPr txBox="1"/>
-          <p:nvPr/>
-        </p:nvSpPr>
-        <p:spPr>
-          <a:xfrm>
-            <a:off x="6949440" y="1234440"/>
-            <a:ext cx="5029200" cy="384048"/>
-          </a:xfrm>
-          <a:prstGeom prst="rect">
-            <a:avLst/>
-          </a:prstGeom>
-          <a:noFill/>
-        </p:spPr>
-        <p:txBody>
-          <a:bodyPr wrap="square">
-            <a:spAutoFit/>
-          </a:bodyPr>
-          <a:lstStyle/>
-          <a:p>
-            <a:pPr algn="l"/>
-            <a:r>
               <a:rPr sz="1600" b="1" i="0">
                 <a:solidFill>
                   <a:srgbClr val="008B8B"/>
@@ -6015,14 +5758,14 @@
       </p:sp>
       <p:sp>
         <p:nvSpPr>
-          <p:cNvPr id="14" name="Rectangle 13"/>
+          <p:cNvPr id="7" name="Rectangle 6"/>
           <p:cNvSpPr/>
           <p:nvPr/>
         </p:nvSpPr>
         <p:spPr>
           <a:xfrm>
-            <a:off x="6949440" y="1691640"/>
-            <a:ext cx="5029200" cy="685800"/>
+            <a:off x="7589520" y="1691640"/>
+            <a:ext cx="4389120" cy="713232"/>
           </a:xfrm>
           <a:prstGeom prst="rect">
             <a:avLst/>
@@ -6058,14 +5801,14 @@
       </p:sp>
       <p:sp>
         <p:nvSpPr>
-          <p:cNvPr id="15" name="TextBox 14"/>
+          <p:cNvPr id="8" name="TextBox 7"/>
           <p:cNvSpPr txBox="1"/>
           <p:nvPr/>
         </p:nvSpPr>
         <p:spPr>
           <a:xfrm>
-            <a:off x="7040880" y="1719072"/>
-            <a:ext cx="4846320" cy="347472"/>
+            <a:off x="7680960" y="1719072"/>
+            <a:ext cx="4206240" cy="347472"/>
           </a:xfrm>
           <a:prstGeom prst="rect">
             <a:avLst/>
@@ -6080,7 +5823,7 @@
           <a:p>
             <a:pPr algn="l"/>
             <a:r>
-              <a:rPr sz="1300" b="1" i="0">
+              <a:rPr sz="1200" b="1" i="0">
                 <a:solidFill>
                   <a:srgbClr val="F5A623"/>
                 </a:solidFill>
@@ -6092,14 +5835,14 @@
       </p:sp>
       <p:sp>
         <p:nvSpPr>
-          <p:cNvPr id="16" name="TextBox 15"/>
+          <p:cNvPr id="9" name="TextBox 8"/>
           <p:cNvSpPr txBox="1"/>
           <p:nvPr/>
         </p:nvSpPr>
         <p:spPr>
           <a:xfrm>
-            <a:off x="7040880" y="2039112"/>
-            <a:ext cx="4846320" cy="301752"/>
+            <a:off x="7680960" y="2057400"/>
+            <a:ext cx="4206240" cy="301752"/>
           </a:xfrm>
           <a:prstGeom prst="rect">
             <a:avLst/>
@@ -6114,7 +5857,7 @@
           <a:p>
             <a:pPr algn="l"/>
             <a:r>
-              <a:rPr sz="1200" b="0" i="0">
+              <a:rPr sz="1100" b="0" i="0">
                 <a:solidFill>
                   <a:srgbClr val="CCCCCC"/>
                 </a:solidFill>
@@ -6126,14 +5869,14 @@
       </p:sp>
       <p:sp>
         <p:nvSpPr>
-          <p:cNvPr id="17" name="Rectangle 16"/>
+          <p:cNvPr id="10" name="Rectangle 9"/>
           <p:cNvSpPr/>
           <p:nvPr/>
         </p:nvSpPr>
         <p:spPr>
           <a:xfrm>
-            <a:off x="6949440" y="2450592"/>
-            <a:ext cx="5029200" cy="685800"/>
+            <a:off x="7589520" y="2496312"/>
+            <a:ext cx="4389120" cy="713232"/>
           </a:xfrm>
           <a:prstGeom prst="rect">
             <a:avLst/>
@@ -6169,14 +5912,14 @@
       </p:sp>
       <p:sp>
         <p:nvSpPr>
-          <p:cNvPr id="18" name="TextBox 17"/>
+          <p:cNvPr id="11" name="TextBox 10"/>
           <p:cNvSpPr txBox="1"/>
           <p:nvPr/>
         </p:nvSpPr>
         <p:spPr>
           <a:xfrm>
-            <a:off x="7040880" y="2478024"/>
-            <a:ext cx="4846320" cy="347472"/>
+            <a:off x="7680960" y="2523744"/>
+            <a:ext cx="4206240" cy="347472"/>
           </a:xfrm>
           <a:prstGeom prst="rect">
             <a:avLst/>
@@ -6191,26 +5934,26 @@
           <a:p>
             <a:pPr algn="l"/>
             <a:r>
-              <a:rPr sz="1300" b="1" i="0">
+              <a:rPr sz="1200" b="1" i="0">
                 <a:solidFill>
                   <a:srgbClr val="F5A623"/>
                 </a:solidFill>
               </a:rPr>
-              <a:t>SHAP Explainability</a:t>
-            </a:r>
-          </a:p>
-        </p:txBody>
-      </p:sp>
-      <p:sp>
-        <p:nvSpPr>
-          <p:cNvPr id="19" name="TextBox 18"/>
+              <a:t>SHAP + LIME + PDP + ICE</a:t>
+            </a:r>
+          </a:p>
+        </p:txBody>
+      </p:sp>
+      <p:sp>
+        <p:nvSpPr>
+          <p:cNvPr id="12" name="TextBox 11"/>
           <p:cNvSpPr txBox="1"/>
           <p:nvPr/>
         </p:nvSpPr>
         <p:spPr>
           <a:xfrm>
-            <a:off x="7040880" y="2798064"/>
-            <a:ext cx="4846320" cy="301752"/>
+            <a:off x="7680960" y="2862072"/>
+            <a:ext cx="4206240" cy="301752"/>
           </a:xfrm>
           <a:prstGeom prst="rect">
             <a:avLst/>
@@ -6225,7 +5968,7 @@
           <a:p>
             <a:pPr algn="l"/>
             <a:r>
-              <a:rPr sz="1200" b="0" i="0">
+              <a:rPr sz="1100" b="0" i="0">
                 <a:solidFill>
                   <a:srgbClr val="CCCCCC"/>
                 </a:solidFill>
@@ -6237,14 +5980,14 @@
       </p:sp>
       <p:sp>
         <p:nvSpPr>
-          <p:cNvPr id="20" name="Rectangle 19"/>
+          <p:cNvPr id="13" name="Rectangle 12"/>
           <p:cNvSpPr/>
           <p:nvPr/>
         </p:nvSpPr>
         <p:spPr>
           <a:xfrm>
-            <a:off x="6949440" y="3209544"/>
-            <a:ext cx="5029200" cy="685800"/>
+            <a:off x="7589520" y="3300984"/>
+            <a:ext cx="4389120" cy="713232"/>
           </a:xfrm>
           <a:prstGeom prst="rect">
             <a:avLst/>
@@ -6280,14 +6023,14 @@
       </p:sp>
       <p:sp>
         <p:nvSpPr>
-          <p:cNvPr id="21" name="TextBox 20"/>
+          <p:cNvPr id="14" name="TextBox 13"/>
           <p:cNvSpPr txBox="1"/>
           <p:nvPr/>
         </p:nvSpPr>
         <p:spPr>
           <a:xfrm>
-            <a:off x="7040880" y="3236976"/>
-            <a:ext cx="4846320" cy="347472"/>
+            <a:off x="7680960" y="3328416"/>
+            <a:ext cx="4206240" cy="347472"/>
           </a:xfrm>
           <a:prstGeom prst="rect">
             <a:avLst/>
@@ -6302,26 +6045,26 @@
           <a:p>
             <a:pPr algn="l"/>
             <a:r>
-              <a:rPr sz="1300" b="1" i="0">
+              <a:rPr sz="1200" b="1" i="0">
                 <a:solidFill>
                   <a:srgbClr val="F5A623"/>
                 </a:solidFill>
               </a:rPr>
-              <a:t>Bias Audit</a:t>
-            </a:r>
-          </a:p>
-        </p:txBody>
-      </p:sp>
-      <p:sp>
-        <p:nvSpPr>
-          <p:cNvPr id="22" name="TextBox 21"/>
+              <a:t>Bias Audit (DIR=0.21)</a:t>
+            </a:r>
+          </a:p>
+        </p:txBody>
+      </p:sp>
+      <p:sp>
+        <p:nvSpPr>
+          <p:cNvPr id="15" name="TextBox 14"/>
           <p:cNvSpPr txBox="1"/>
           <p:nvPr/>
         </p:nvSpPr>
         <p:spPr>
           <a:xfrm>
-            <a:off x="7040880" y="3557016"/>
-            <a:ext cx="4846320" cy="301752"/>
+            <a:off x="7680960" y="3666744"/>
+            <a:ext cx="4206240" cy="301752"/>
           </a:xfrm>
           <a:prstGeom prst="rect">
             <a:avLst/>
@@ -6336,26 +6079,26 @@
           <a:p>
             <a:pPr algn="l"/>
             <a:r>
-              <a:rPr sz="1200" b="0" i="0">
+              <a:rPr sz="1100" b="0" i="0">
                 <a:solidFill>
                   <a:srgbClr val="CCCCCC"/>
                 </a:solidFill>
               </a:rPr>
-              <a:t>No significant bias across subgroups</a:t>
-            </a:r>
-          </a:p>
-        </p:txBody>
-      </p:sp>
-      <p:sp>
-        <p:nvSpPr>
-          <p:cNvPr id="23" name="Rectangle 22"/>
+              <a:t>Protocol-level disparate impact explained</a:t>
+            </a:r>
+          </a:p>
+        </p:txBody>
+      </p:sp>
+      <p:sp>
+        <p:nvSpPr>
+          <p:cNvPr id="16" name="Rectangle 15"/>
           <p:cNvSpPr/>
           <p:nvPr/>
         </p:nvSpPr>
         <p:spPr>
           <a:xfrm>
-            <a:off x="6949440" y="3968496"/>
-            <a:ext cx="5029200" cy="685800"/>
+            <a:off x="7589520" y="4105656"/>
+            <a:ext cx="4389120" cy="713232"/>
           </a:xfrm>
           <a:prstGeom prst="rect">
             <a:avLst/>
@@ -6391,14 +6134,14 @@
       </p:sp>
       <p:sp>
         <p:nvSpPr>
-          <p:cNvPr id="24" name="TextBox 23"/>
+          <p:cNvPr id="17" name="TextBox 16"/>
           <p:cNvSpPr txBox="1"/>
           <p:nvPr/>
         </p:nvSpPr>
         <p:spPr>
           <a:xfrm>
-            <a:off x="7040880" y="3995928"/>
-            <a:ext cx="4846320" cy="347472"/>
+            <a:off x="7680960" y="4133088"/>
+            <a:ext cx="4206240" cy="347472"/>
           </a:xfrm>
           <a:prstGeom prst="rect">
             <a:avLst/>
@@ -6413,26 +6156,26 @@
           <a:p>
             <a:pPr algn="l"/>
             <a:r>
-              <a:rPr sz="1300" b="1" i="0">
+              <a:rPr sz="1200" b="1" i="0">
                 <a:solidFill>
                   <a:srgbClr val="F5A623"/>
                 </a:solidFill>
               </a:rPr>
-              <a:t>FastAPI Deployment</a:t>
-            </a:r>
-          </a:p>
-        </p:txBody>
-      </p:sp>
-      <p:sp>
-        <p:nvSpPr>
-          <p:cNvPr id="25" name="TextBox 24"/>
+              <a:t>FastAPI + Streamlit</a:t>
+            </a:r>
+          </a:p>
+        </p:txBody>
+      </p:sp>
+      <p:sp>
+        <p:nvSpPr>
+          <p:cNvPr id="18" name="TextBox 17"/>
           <p:cNvSpPr txBox="1"/>
           <p:nvPr/>
         </p:nvSpPr>
         <p:spPr>
           <a:xfrm>
-            <a:off x="7040880" y="4315968"/>
-            <a:ext cx="4846320" cy="301752"/>
+            <a:off x="7680960" y="4471416"/>
+            <a:ext cx="4206240" cy="301752"/>
           </a:xfrm>
           <a:prstGeom prst="rect">
             <a:avLst/>
@@ -6447,26 +6190,26 @@
           <a:p>
             <a:pPr algn="l"/>
             <a:r>
-              <a:rPr sz="1200" b="0" i="0">
+              <a:rPr sz="1100" b="0" i="0">
                 <a:solidFill>
                   <a:srgbClr val="CCCCCC"/>
                 </a:solidFill>
               </a:rPr>
-              <a:t>Input validation + X-From enforcement</a:t>
-            </a:r>
-          </a:p>
-        </p:txBody>
-      </p:sp>
-      <p:sp>
-        <p:nvSpPr>
-          <p:cNvPr id="26" name="Rectangle 25"/>
+              <a:t>Input validation + X-From traceability</a:t>
+            </a:r>
+          </a:p>
+        </p:txBody>
+      </p:sp>
+      <p:sp>
+        <p:nvSpPr>
+          <p:cNvPr id="19" name="Rectangle 18"/>
           <p:cNvSpPr/>
           <p:nvPr/>
         </p:nvSpPr>
         <p:spPr>
           <a:xfrm>
-            <a:off x="6949440" y="4727448"/>
-            <a:ext cx="5029200" cy="685800"/>
+            <a:off x="7589520" y="4910328"/>
+            <a:ext cx="4389120" cy="713232"/>
           </a:xfrm>
           <a:prstGeom prst="rect">
             <a:avLst/>
@@ -6502,14 +6245,14 @@
       </p:sp>
       <p:sp>
         <p:nvSpPr>
-          <p:cNvPr id="27" name="TextBox 26"/>
+          <p:cNvPr id="20" name="TextBox 19"/>
           <p:cNvSpPr txBox="1"/>
           <p:nvPr/>
         </p:nvSpPr>
         <p:spPr>
           <a:xfrm>
-            <a:off x="7040880" y="4754880"/>
-            <a:ext cx="4846320" cy="347472"/>
+            <a:off x="7680960" y="4937760"/>
+            <a:ext cx="4206240" cy="347472"/>
           </a:xfrm>
           <a:prstGeom prst="rect">
             <a:avLst/>
@@ -6524,7 +6267,7 @@
           <a:p>
             <a:pPr algn="l"/>
             <a:r>
-              <a:rPr sz="1300" b="1" i="0">
+              <a:rPr sz="1200" b="1" i="0">
                 <a:solidFill>
                   <a:srgbClr val="F5A623"/>
                 </a:solidFill>
@@ -6536,14 +6279,14 @@
       </p:sp>
       <p:sp>
         <p:nvSpPr>
-          <p:cNvPr id="28" name="TextBox 27"/>
+          <p:cNvPr id="21" name="TextBox 20"/>
           <p:cNvSpPr txBox="1"/>
           <p:nvPr/>
         </p:nvSpPr>
         <p:spPr>
           <a:xfrm>
-            <a:off x="7040880" y="5074920"/>
-            <a:ext cx="4846320" cy="301752"/>
+            <a:off x="7680960" y="5276088"/>
+            <a:ext cx="4206240" cy="301752"/>
           </a:xfrm>
           <a:prstGeom prst="rect">
             <a:avLst/>
@@ -6558,7 +6301,7 @@
           <a:p>
             <a:pPr algn="l"/>
             <a:r>
-              <a:rPr sz="1200" b="0" i="0">
+              <a:rPr sz="1100" b="0" i="0">
                 <a:solidFill>
                   <a:srgbClr val="CCCCCC"/>
                 </a:solidFill>
@@ -6570,14 +6313,14 @@
       </p:sp>
       <p:sp>
         <p:nvSpPr>
-          <p:cNvPr id="29" name="Rectangle 28"/>
+          <p:cNvPr id="22" name="Rectangle 21"/>
           <p:cNvSpPr/>
           <p:nvPr/>
         </p:nvSpPr>
         <p:spPr>
           <a:xfrm>
-            <a:off x="365760" y="5577840"/>
-            <a:ext cx="11430000" cy="502920"/>
+            <a:off x="365760" y="6172200"/>
+            <a:ext cx="11430000" cy="438912"/>
           </a:xfrm>
           <a:prstGeom prst="rect">
             <a:avLst/>
@@ -6613,14 +6356,14 @@
       </p:sp>
       <p:sp>
         <p:nvSpPr>
-          <p:cNvPr id="30" name="TextBox 29"/>
+          <p:cNvPr id="23" name="TextBox 22"/>
           <p:cNvSpPr txBox="1"/>
           <p:nvPr/>
         </p:nvSpPr>
         <p:spPr>
           <a:xfrm>
-            <a:off x="457200" y="5623560"/>
-            <a:ext cx="11155680" cy="384048"/>
+            <a:off x="457200" y="6199632"/>
+            <a:ext cx="11155680" cy="347472"/>
           </a:xfrm>
           <a:prstGeom prst="rect">
             <a:avLst/>
@@ -6635,7 +6378,7 @@
           <a:p>
             <a:pPr algn="ctr"/>
             <a:r>
-              <a:rPr sz="1200" b="0" i="1">
+              <a:rPr sz="1100" b="0" i="1">
                 <a:solidFill>
                   <a:srgbClr val="FFFFFF"/>
                 </a:solidFill>

</xml_diff>

<commit_message>
Correcting the docstring and implementation of the `get_feature_names` function to accurately reflect its purpose and functionality.
</commit_message>
<xml_diff>
--- a/presentations/technical/technical_presentation.pptx
+++ b/presentations/technical/technical_presentation.pptx
@@ -5,20 +5,20 @@
     <p:sldMasterId id="2147483648" r:id="rId1"/>
   </p:sldMasterIdLst>
   <p:sldIdLst>
-    <p:sldId id="256" r:id="rId7"/>
-    <p:sldId id="257" r:id="rId8"/>
-    <p:sldId id="258" r:id="rId9"/>
-    <p:sldId id="259" r:id="rId10"/>
-    <p:sldId id="260" r:id="rId11"/>
-    <p:sldId id="261" r:id="rId12"/>
-    <p:sldId id="262" r:id="rId13"/>
-    <p:sldId id="263" r:id="rId14"/>
-    <p:sldId id="264" r:id="rId15"/>
-    <p:sldId id="265" r:id="rId16"/>
-    <p:sldId id="266" r:id="rId17"/>
-    <p:sldId id="267" r:id="rId18"/>
+    <p:sldId id="256" r:id="rId2"/>
+    <p:sldId id="257" r:id="rId3"/>
+    <p:sldId id="258" r:id="rId4"/>
+    <p:sldId id="259" r:id="rId5"/>
+    <p:sldId id="260" r:id="rId6"/>
+    <p:sldId id="261" r:id="rId7"/>
+    <p:sldId id="262" r:id="rId8"/>
+    <p:sldId id="263" r:id="rId9"/>
+    <p:sldId id="264" r:id="rId10"/>
+    <p:sldId id="265" r:id="rId11"/>
+    <p:sldId id="266" r:id="rId12"/>
+    <p:sldId id="267" r:id="rId13"/>
   </p:sldIdLst>
-  <p:sldSz cx="12188952" cy="6858000" type="screen4x3"/>
+  <p:sldSz cx="12188825" cy="6858000"/>
   <p:notesSz cx="6858000" cy="9144000"/>
   <p:defaultTextStyle>
     <a:defPPr>
@@ -115,6 +115,22 @@
       </a:defRPr>
     </a:lvl9pPr>
   </p:defaultTextStyle>
+  <p:extLst>
+    <p:ext uri="{EFAFB233-063F-42B5-8137-9DF3F51BA10A}">
+      <p15:sldGuideLst xmlns:p15="http://schemas.microsoft.com/office/powerpoint/2012/main">
+        <p15:guide id="1" orient="horz" pos="2160">
+          <p15:clr>
+            <a:srgbClr val="A4A3A4"/>
+          </p15:clr>
+        </p15:guide>
+        <p15:guide id="2" pos="2880">
+          <p15:clr>
+            <a:srgbClr val="A4A3A4"/>
+          </p15:clr>
+        </p15:guide>
+      </p15:sldGuideLst>
+    </p:ext>
+  </p:extLst>
 </p:presentation>
 </file>
 
@@ -156,10 +172,9 @@
           <a:lstStyle/>
           <a:p>
             <a:r>
-              <a:rPr lang="en-US" smtClean="0"/>
+              <a:rPr lang="en-US"/>
               <a:t>Click to edit Master title style</a:t>
             </a:r>
-            <a:endParaRPr lang="en-US"/>
           </a:p>
         </p:txBody>
       </p:sp>
@@ -275,10 +290,9 @@
           </a:lstStyle>
           <a:p>
             <a:r>
-              <a:rPr lang="en-US" smtClean="0"/>
+              <a:rPr lang="en-US"/>
               <a:t>Click to edit Master subtitle style</a:t>
             </a:r>
-            <a:endParaRPr lang="en-US"/>
           </a:p>
         </p:txBody>
       </p:sp>
@@ -299,7 +313,7 @@
           <a:p>
             <a:fld id="{5BCAD085-E8A6-8845-BD4E-CB4CCA059FC4}" type="datetimeFigureOut">
               <a:rPr lang="en-US" smtClean="0"/>
-              <a:t>1/27/13</a:t>
+              <a:t>7/16/26</a:t>
             </a:fld>
             <a:endParaRPr lang="en-US"/>
           </a:p>
@@ -393,10 +407,9 @@
           <a:lstStyle/>
           <a:p>
             <a:r>
-              <a:rPr lang="en-US" smtClean="0"/>
+              <a:rPr lang="en-US"/>
               <a:t>Click to edit Master title style</a:t>
             </a:r>
-            <a:endParaRPr lang="en-US"/>
           </a:p>
         </p:txBody>
       </p:sp>
@@ -417,38 +430,37 @@
           <a:p>
             <a:pPr lvl="0"/>
             <a:r>
-              <a:rPr lang="en-US" smtClean="0"/>
+              <a:rPr lang="en-US"/>
               <a:t>Click to edit Master text styles</a:t>
             </a:r>
           </a:p>
           <a:p>
             <a:pPr lvl="1"/>
             <a:r>
-              <a:rPr lang="en-US" smtClean="0"/>
+              <a:rPr lang="en-US"/>
               <a:t>Second level</a:t>
             </a:r>
           </a:p>
           <a:p>
             <a:pPr lvl="2"/>
             <a:r>
-              <a:rPr lang="en-US" smtClean="0"/>
+              <a:rPr lang="en-US"/>
               <a:t>Third level</a:t>
             </a:r>
           </a:p>
           <a:p>
             <a:pPr lvl="3"/>
             <a:r>
-              <a:rPr lang="en-US" smtClean="0"/>
+              <a:rPr lang="en-US"/>
               <a:t>Fourth level</a:t>
             </a:r>
           </a:p>
           <a:p>
             <a:pPr lvl="4"/>
             <a:r>
-              <a:rPr lang="en-US" smtClean="0"/>
+              <a:rPr lang="en-US"/>
               <a:t>Fifth level</a:t>
             </a:r>
-            <a:endParaRPr lang="en-US"/>
           </a:p>
         </p:txBody>
       </p:sp>
@@ -469,7 +481,7 @@
           <a:p>
             <a:fld id="{5BCAD085-E8A6-8845-BD4E-CB4CCA059FC4}" type="datetimeFigureOut">
               <a:rPr lang="en-US" smtClean="0"/>
-              <a:t>1/27/13</a:t>
+              <a:t>7/16/26</a:t>
             </a:fld>
             <a:endParaRPr lang="en-US"/>
           </a:p>
@@ -568,10 +580,9 @@
           <a:lstStyle/>
           <a:p>
             <a:r>
-              <a:rPr lang="en-US" smtClean="0"/>
+              <a:rPr lang="en-US"/>
               <a:t>Click to edit Master title style</a:t>
             </a:r>
-            <a:endParaRPr lang="en-US"/>
           </a:p>
         </p:txBody>
       </p:sp>
@@ -597,38 +608,37 @@
           <a:p>
             <a:pPr lvl="0"/>
             <a:r>
-              <a:rPr lang="en-US" smtClean="0"/>
+              <a:rPr lang="en-US"/>
               <a:t>Click to edit Master text styles</a:t>
             </a:r>
           </a:p>
           <a:p>
             <a:pPr lvl="1"/>
             <a:r>
-              <a:rPr lang="en-US" smtClean="0"/>
+              <a:rPr lang="en-US"/>
               <a:t>Second level</a:t>
             </a:r>
           </a:p>
           <a:p>
             <a:pPr lvl="2"/>
             <a:r>
-              <a:rPr lang="en-US" smtClean="0"/>
+              <a:rPr lang="en-US"/>
               <a:t>Third level</a:t>
             </a:r>
           </a:p>
           <a:p>
             <a:pPr lvl="3"/>
             <a:r>
-              <a:rPr lang="en-US" smtClean="0"/>
+              <a:rPr lang="en-US"/>
               <a:t>Fourth level</a:t>
             </a:r>
           </a:p>
           <a:p>
             <a:pPr lvl="4"/>
             <a:r>
-              <a:rPr lang="en-US" smtClean="0"/>
+              <a:rPr lang="en-US"/>
               <a:t>Fifth level</a:t>
             </a:r>
-            <a:endParaRPr lang="en-US"/>
           </a:p>
         </p:txBody>
       </p:sp>
@@ -649,7 +659,7 @@
           <a:p>
             <a:fld id="{5BCAD085-E8A6-8845-BD4E-CB4CCA059FC4}" type="datetimeFigureOut">
               <a:rPr lang="en-US" smtClean="0"/>
-              <a:t>1/27/13</a:t>
+              <a:t>7/16/26</a:t>
             </a:fld>
             <a:endParaRPr lang="en-US"/>
           </a:p>
@@ -743,10 +753,9 @@
           <a:lstStyle/>
           <a:p>
             <a:r>
-              <a:rPr lang="en-US" smtClean="0"/>
+              <a:rPr lang="en-US"/>
               <a:t>Click to edit Master title style</a:t>
             </a:r>
-            <a:endParaRPr lang="en-US"/>
           </a:p>
         </p:txBody>
       </p:sp>
@@ -767,38 +776,37 @@
           <a:p>
             <a:pPr lvl="0"/>
             <a:r>
-              <a:rPr lang="en-US" smtClean="0"/>
+              <a:rPr lang="en-US"/>
               <a:t>Click to edit Master text styles</a:t>
             </a:r>
           </a:p>
           <a:p>
             <a:pPr lvl="1"/>
             <a:r>
-              <a:rPr lang="en-US" smtClean="0"/>
+              <a:rPr lang="en-US"/>
               <a:t>Second level</a:t>
             </a:r>
           </a:p>
           <a:p>
             <a:pPr lvl="2"/>
             <a:r>
-              <a:rPr lang="en-US" smtClean="0"/>
+              <a:rPr lang="en-US"/>
               <a:t>Third level</a:t>
             </a:r>
           </a:p>
           <a:p>
             <a:pPr lvl="3"/>
             <a:r>
-              <a:rPr lang="en-US" smtClean="0"/>
+              <a:rPr lang="en-US"/>
               <a:t>Fourth level</a:t>
             </a:r>
           </a:p>
           <a:p>
             <a:pPr lvl="4"/>
             <a:r>
-              <a:rPr lang="en-US" smtClean="0"/>
+              <a:rPr lang="en-US"/>
               <a:t>Fifth level</a:t>
             </a:r>
-            <a:endParaRPr lang="en-US"/>
           </a:p>
         </p:txBody>
       </p:sp>
@@ -819,7 +827,7 @@
           <a:p>
             <a:fld id="{5BCAD085-E8A6-8845-BD4E-CB4CCA059FC4}" type="datetimeFigureOut">
               <a:rPr lang="en-US" smtClean="0"/>
-              <a:t>1/27/13</a:t>
+              <a:t>7/16/26</a:t>
             </a:fld>
             <a:endParaRPr lang="en-US"/>
           </a:p>
@@ -922,10 +930,9 @@
           </a:lstStyle>
           <a:p>
             <a:r>
-              <a:rPr lang="en-US" smtClean="0"/>
+              <a:rPr lang="en-US"/>
               <a:t>Click to edit Master title style</a:t>
             </a:r>
-            <a:endParaRPr lang="en-US"/>
           </a:p>
         </p:txBody>
       </p:sp>
@@ -1042,7 +1049,7 @@
           <a:p>
             <a:pPr lvl="0"/>
             <a:r>
-              <a:rPr lang="en-US" smtClean="0"/>
+              <a:rPr lang="en-US"/>
               <a:t>Click to edit Master text styles</a:t>
             </a:r>
           </a:p>
@@ -1065,7 +1072,7 @@
           <a:p>
             <a:fld id="{5BCAD085-E8A6-8845-BD4E-CB4CCA059FC4}" type="datetimeFigureOut">
               <a:rPr lang="en-US" smtClean="0"/>
-              <a:t>1/27/13</a:t>
+              <a:t>7/16/26</a:t>
             </a:fld>
             <a:endParaRPr lang="en-US"/>
           </a:p>
@@ -1159,10 +1166,9 @@
           <a:lstStyle/>
           <a:p>
             <a:r>
-              <a:rPr lang="en-US" smtClean="0"/>
+              <a:rPr lang="en-US"/>
               <a:t>Click to edit Master title style</a:t>
             </a:r>
-            <a:endParaRPr lang="en-US"/>
           </a:p>
         </p:txBody>
       </p:sp>
@@ -1216,38 +1222,37 @@
           <a:p>
             <a:pPr lvl="0"/>
             <a:r>
-              <a:rPr lang="en-US" smtClean="0"/>
+              <a:rPr lang="en-US"/>
               <a:t>Click to edit Master text styles</a:t>
             </a:r>
           </a:p>
           <a:p>
             <a:pPr lvl="1"/>
             <a:r>
-              <a:rPr lang="en-US" smtClean="0"/>
+              <a:rPr lang="en-US"/>
               <a:t>Second level</a:t>
             </a:r>
           </a:p>
           <a:p>
             <a:pPr lvl="2"/>
             <a:r>
-              <a:rPr lang="en-US" smtClean="0"/>
+              <a:rPr lang="en-US"/>
               <a:t>Third level</a:t>
             </a:r>
           </a:p>
           <a:p>
             <a:pPr lvl="3"/>
             <a:r>
-              <a:rPr lang="en-US" smtClean="0"/>
+              <a:rPr lang="en-US"/>
               <a:t>Fourth level</a:t>
             </a:r>
           </a:p>
           <a:p>
             <a:pPr lvl="4"/>
             <a:r>
-              <a:rPr lang="en-US" smtClean="0"/>
+              <a:rPr lang="en-US"/>
               <a:t>Fifth level</a:t>
             </a:r>
-            <a:endParaRPr lang="en-US"/>
           </a:p>
         </p:txBody>
       </p:sp>
@@ -1301,38 +1306,37 @@
           <a:p>
             <a:pPr lvl="0"/>
             <a:r>
-              <a:rPr lang="en-US" smtClean="0"/>
+              <a:rPr lang="en-US"/>
               <a:t>Click to edit Master text styles</a:t>
             </a:r>
           </a:p>
           <a:p>
             <a:pPr lvl="1"/>
             <a:r>
-              <a:rPr lang="en-US" smtClean="0"/>
+              <a:rPr lang="en-US"/>
               <a:t>Second level</a:t>
             </a:r>
           </a:p>
           <a:p>
             <a:pPr lvl="2"/>
             <a:r>
-              <a:rPr lang="en-US" smtClean="0"/>
+              <a:rPr lang="en-US"/>
               <a:t>Third level</a:t>
             </a:r>
           </a:p>
           <a:p>
             <a:pPr lvl="3"/>
             <a:r>
-              <a:rPr lang="en-US" smtClean="0"/>
+              <a:rPr lang="en-US"/>
               <a:t>Fourth level</a:t>
             </a:r>
           </a:p>
           <a:p>
             <a:pPr lvl="4"/>
             <a:r>
-              <a:rPr lang="en-US" smtClean="0"/>
+              <a:rPr lang="en-US"/>
               <a:t>Fifth level</a:t>
             </a:r>
-            <a:endParaRPr lang="en-US"/>
           </a:p>
         </p:txBody>
       </p:sp>
@@ -1353,7 +1357,7 @@
           <a:p>
             <a:fld id="{5BCAD085-E8A6-8845-BD4E-CB4CCA059FC4}" type="datetimeFigureOut">
               <a:rPr lang="en-US" smtClean="0"/>
-              <a:t>1/27/13</a:t>
+              <a:t>7/16/26</a:t>
             </a:fld>
             <a:endParaRPr lang="en-US"/>
           </a:p>
@@ -1451,10 +1455,9 @@
           </a:lstStyle>
           <a:p>
             <a:r>
-              <a:rPr lang="en-US" smtClean="0"/>
+              <a:rPr lang="en-US"/>
               <a:t>Click to edit Master title style</a:t>
             </a:r>
-            <a:endParaRPr lang="en-US"/>
           </a:p>
         </p:txBody>
       </p:sp>
@@ -1517,7 +1520,7 @@
           <a:p>
             <a:pPr lvl="0"/>
             <a:r>
-              <a:rPr lang="en-US" smtClean="0"/>
+              <a:rPr lang="en-US"/>
               <a:t>Click to edit Master text styles</a:t>
             </a:r>
           </a:p>
@@ -1573,38 +1576,37 @@
           <a:p>
             <a:pPr lvl="0"/>
             <a:r>
-              <a:rPr lang="en-US" smtClean="0"/>
+              <a:rPr lang="en-US"/>
               <a:t>Click to edit Master text styles</a:t>
             </a:r>
           </a:p>
           <a:p>
             <a:pPr lvl="1"/>
             <a:r>
-              <a:rPr lang="en-US" smtClean="0"/>
+              <a:rPr lang="en-US"/>
               <a:t>Second level</a:t>
             </a:r>
           </a:p>
           <a:p>
             <a:pPr lvl="2"/>
             <a:r>
-              <a:rPr lang="en-US" smtClean="0"/>
+              <a:rPr lang="en-US"/>
               <a:t>Third level</a:t>
             </a:r>
           </a:p>
           <a:p>
             <a:pPr lvl="3"/>
             <a:r>
-              <a:rPr lang="en-US" smtClean="0"/>
+              <a:rPr lang="en-US"/>
               <a:t>Fourth level</a:t>
             </a:r>
           </a:p>
           <a:p>
             <a:pPr lvl="4"/>
             <a:r>
-              <a:rPr lang="en-US" smtClean="0"/>
+              <a:rPr lang="en-US"/>
               <a:t>Fifth level</a:t>
             </a:r>
-            <a:endParaRPr lang="en-US"/>
           </a:p>
         </p:txBody>
       </p:sp>
@@ -1667,7 +1669,7 @@
           <a:p>
             <a:pPr lvl="0"/>
             <a:r>
-              <a:rPr lang="en-US" smtClean="0"/>
+              <a:rPr lang="en-US"/>
               <a:t>Click to edit Master text styles</a:t>
             </a:r>
           </a:p>
@@ -1723,38 +1725,37 @@
           <a:p>
             <a:pPr lvl="0"/>
             <a:r>
-              <a:rPr lang="en-US" smtClean="0"/>
+              <a:rPr lang="en-US"/>
               <a:t>Click to edit Master text styles</a:t>
             </a:r>
           </a:p>
           <a:p>
             <a:pPr lvl="1"/>
             <a:r>
-              <a:rPr lang="en-US" smtClean="0"/>
+              <a:rPr lang="en-US"/>
               <a:t>Second level</a:t>
             </a:r>
           </a:p>
           <a:p>
             <a:pPr lvl="2"/>
             <a:r>
-              <a:rPr lang="en-US" smtClean="0"/>
+              <a:rPr lang="en-US"/>
               <a:t>Third level</a:t>
             </a:r>
           </a:p>
           <a:p>
             <a:pPr lvl="3"/>
             <a:r>
-              <a:rPr lang="en-US" smtClean="0"/>
+              <a:rPr lang="en-US"/>
               <a:t>Fourth level</a:t>
             </a:r>
           </a:p>
           <a:p>
             <a:pPr lvl="4"/>
             <a:r>
-              <a:rPr lang="en-US" smtClean="0"/>
+              <a:rPr lang="en-US"/>
               <a:t>Fifth level</a:t>
             </a:r>
-            <a:endParaRPr lang="en-US"/>
           </a:p>
         </p:txBody>
       </p:sp>
@@ -1775,7 +1776,7 @@
           <a:p>
             <a:fld id="{5BCAD085-E8A6-8845-BD4E-CB4CCA059FC4}" type="datetimeFigureOut">
               <a:rPr lang="en-US" smtClean="0"/>
-              <a:t>1/27/13</a:t>
+              <a:t>7/16/26</a:t>
             </a:fld>
             <a:endParaRPr lang="en-US"/>
           </a:p>
@@ -1869,10 +1870,9 @@
           <a:lstStyle/>
           <a:p>
             <a:r>
-              <a:rPr lang="en-US" smtClean="0"/>
+              <a:rPr lang="en-US"/>
               <a:t>Click to edit Master title style</a:t>
             </a:r>
-            <a:endParaRPr lang="en-US"/>
           </a:p>
         </p:txBody>
       </p:sp>
@@ -1893,7 +1893,7 @@
           <a:p>
             <a:fld id="{5BCAD085-E8A6-8845-BD4E-CB4CCA059FC4}" type="datetimeFigureOut">
               <a:rPr lang="en-US" smtClean="0"/>
-              <a:t>1/27/13</a:t>
+              <a:t>7/16/26</a:t>
             </a:fld>
             <a:endParaRPr lang="en-US"/>
           </a:p>
@@ -1988,7 +1988,7 @@
           <a:p>
             <a:fld id="{5BCAD085-E8A6-8845-BD4E-CB4CCA059FC4}" type="datetimeFigureOut">
               <a:rPr lang="en-US" smtClean="0"/>
-              <a:t>1/27/13</a:t>
+              <a:t>7/16/26</a:t>
             </a:fld>
             <a:endParaRPr lang="en-US"/>
           </a:p>
@@ -2091,10 +2091,9 @@
           </a:lstStyle>
           <a:p>
             <a:r>
-              <a:rPr lang="en-US" smtClean="0"/>
+              <a:rPr lang="en-US"/>
               <a:t>Click to edit Master title style</a:t>
             </a:r>
-            <a:endParaRPr lang="en-US"/>
           </a:p>
         </p:txBody>
       </p:sp>
@@ -2148,38 +2147,37 @@
           <a:p>
             <a:pPr lvl="0"/>
             <a:r>
-              <a:rPr lang="en-US" smtClean="0"/>
+              <a:rPr lang="en-US"/>
               <a:t>Click to edit Master text styles</a:t>
             </a:r>
           </a:p>
           <a:p>
             <a:pPr lvl="1"/>
             <a:r>
-              <a:rPr lang="en-US" smtClean="0"/>
+              <a:rPr lang="en-US"/>
               <a:t>Second level</a:t>
             </a:r>
           </a:p>
           <a:p>
             <a:pPr lvl="2"/>
             <a:r>
-              <a:rPr lang="en-US" smtClean="0"/>
+              <a:rPr lang="en-US"/>
               <a:t>Third level</a:t>
             </a:r>
           </a:p>
           <a:p>
             <a:pPr lvl="3"/>
             <a:r>
-              <a:rPr lang="en-US" smtClean="0"/>
+              <a:rPr lang="en-US"/>
               <a:t>Fourth level</a:t>
             </a:r>
           </a:p>
           <a:p>
             <a:pPr lvl="4"/>
             <a:r>
-              <a:rPr lang="en-US" smtClean="0"/>
+              <a:rPr lang="en-US"/>
               <a:t>Fifth level</a:t>
             </a:r>
-            <a:endParaRPr lang="en-US"/>
           </a:p>
         </p:txBody>
       </p:sp>
@@ -2242,7 +2240,7 @@
           <a:p>
             <a:pPr lvl="0"/>
             <a:r>
-              <a:rPr lang="en-US" smtClean="0"/>
+              <a:rPr lang="en-US"/>
               <a:t>Click to edit Master text styles</a:t>
             </a:r>
           </a:p>
@@ -2265,7 +2263,7 @@
           <a:p>
             <a:fld id="{5BCAD085-E8A6-8845-BD4E-CB4CCA059FC4}" type="datetimeFigureOut">
               <a:rPr lang="en-US" smtClean="0"/>
-              <a:t>1/27/13</a:t>
+              <a:t>7/16/26</a:t>
             </a:fld>
             <a:endParaRPr lang="en-US"/>
           </a:p>
@@ -2368,10 +2366,9 @@
           </a:lstStyle>
           <a:p>
             <a:r>
-              <a:rPr lang="en-US" smtClean="0"/>
+              <a:rPr lang="en-US"/>
               <a:t>Click to edit Master title style</a:t>
             </a:r>
-            <a:endParaRPr lang="en-US"/>
           </a:p>
         </p:txBody>
       </p:sp>
@@ -2495,7 +2492,7 @@
           <a:p>
             <a:pPr lvl="0"/>
             <a:r>
-              <a:rPr lang="en-US" smtClean="0"/>
+              <a:rPr lang="en-US"/>
               <a:t>Click to edit Master text styles</a:t>
             </a:r>
           </a:p>
@@ -2518,7 +2515,7 @@
           <a:p>
             <a:fld id="{5BCAD085-E8A6-8845-BD4E-CB4CCA059FC4}" type="datetimeFigureOut">
               <a:rPr lang="en-US" smtClean="0"/>
-              <a:t>1/27/13</a:t>
+              <a:t>7/16/26</a:t>
             </a:fld>
             <a:endParaRPr lang="en-US"/>
           </a:p>
@@ -2627,10 +2624,9 @@
           <a:lstStyle/>
           <a:p>
             <a:r>
-              <a:rPr lang="en-US" smtClean="0"/>
+              <a:rPr lang="en-US"/>
               <a:t>Click to edit Master title style</a:t>
             </a:r>
-            <a:endParaRPr lang="en-US"/>
           </a:p>
         </p:txBody>
       </p:sp>
@@ -2661,38 +2657,37 @@
           <a:p>
             <a:pPr lvl="0"/>
             <a:r>
-              <a:rPr lang="en-US" smtClean="0"/>
+              <a:rPr lang="en-US"/>
               <a:t>Click to edit Master text styles</a:t>
             </a:r>
           </a:p>
           <a:p>
             <a:pPr lvl="1"/>
             <a:r>
-              <a:rPr lang="en-US" smtClean="0"/>
+              <a:rPr lang="en-US"/>
               <a:t>Second level</a:t>
             </a:r>
           </a:p>
           <a:p>
             <a:pPr lvl="2"/>
             <a:r>
-              <a:rPr lang="en-US" smtClean="0"/>
+              <a:rPr lang="en-US"/>
               <a:t>Third level</a:t>
             </a:r>
           </a:p>
           <a:p>
             <a:pPr lvl="3"/>
             <a:r>
-              <a:rPr lang="en-US" smtClean="0"/>
+              <a:rPr lang="en-US"/>
               <a:t>Fourth level</a:t>
             </a:r>
           </a:p>
           <a:p>
             <a:pPr lvl="4"/>
             <a:r>
-              <a:rPr lang="en-US" smtClean="0"/>
+              <a:rPr lang="en-US"/>
               <a:t>Fifth level</a:t>
             </a:r>
-            <a:endParaRPr lang="en-US"/>
           </a:p>
         </p:txBody>
       </p:sp>
@@ -2731,7 +2726,7 @@
           <a:p>
             <a:fld id="{5BCAD085-E8A6-8845-BD4E-CB4CCA059FC4}" type="datetimeFigureOut">
               <a:rPr lang="en-US" smtClean="0"/>
-              <a:t>1/27/13</a:t>
+              <a:t>7/16/26</a:t>
             </a:fld>
             <a:endParaRPr lang="en-US"/>
           </a:p>
@@ -2812,6 +2807,54 @@
               <a:t>‹#›</a:t>
             </a:fld>
             <a:endParaRPr lang="en-US"/>
+          </a:p>
+        </p:txBody>
+      </p:sp>
+      <p:sp>
+        <p:nvSpPr>
+          <p:cNvPr id="8" name="TextBox 7">
+            <a:extLst>
+              <a:ext uri="{FF2B5EF4-FFF2-40B4-BE49-F238E27FC236}">
+                <a16:creationId xmlns:a16="http://schemas.microsoft.com/office/drawing/2014/main" id="{2E07F293-91FA-64E6-3E20-328876DC1EC7}"/>
+              </a:ext>
+            </a:extLst>
+          </p:cNvPr>
+          <p:cNvSpPr txBox="1"/>
+          <p:nvPr userDrawn="1">
+            <p:extLst>
+              <p:ext uri="{1162E1C5-73C7-4A58-AE30-91384D911F3F}">
+                <p184:classification xmlns:p184="http://schemas.microsoft.com/office/powerpoint/2018/4/main" val="ftr"/>
+              </p:ext>
+            </p:extLst>
+          </p:nvPr>
+        </p:nvSpPr>
+        <p:spPr>
+          <a:xfrm>
+            <a:off x="5591175" y="6687820"/>
+            <a:ext cx="1023938" cy="106680"/>
+          </a:xfrm>
+          <a:prstGeom prst="rect">
+            <a:avLst/>
+          </a:prstGeom>
+        </p:spPr>
+        <p:txBody>
+          <a:bodyPr horzOverflow="overflow" lIns="0" tIns="0" rIns="0" bIns="0">
+            <a:spAutoFit/>
+          </a:bodyPr>
+          <a:lstStyle/>
+          <a:p>
+            <a:pPr algn="l"/>
+            <a:r>
+              <a:rPr lang="en-US" sz="700">
+                <a:solidFill>
+                  <a:srgbClr val="000000">
+                    <a:alpha val="50000"/>
+                  </a:srgbClr>
+                </a:solidFill>
+                <a:latin typeface="Aptos" panose="020B0004020202020204" pitchFamily="34" charset="0"/>
+              </a:rPr>
+              <a:t>Juniper Business Use Only</a:t>
+            </a:r>
           </a:p>
         </p:txBody>
       </p:sp>
@@ -3090,7 +3133,7 @@
 </file>
 
 <file path=ppt/slides/slide1.xml><?xml version="1.0" encoding="utf-8"?>
-<p:sld xmlns:a="http://schemas.openxmlformats.org/drawingml/2006/main" xmlns:p="http://schemas.openxmlformats.org/presentationml/2006/main" xmlns:r="http://schemas.openxmlformats.org/officeDocument/2006/relationships">
+<p:sld xmlns:a="http://schemas.openxmlformats.org/drawingml/2006/main" xmlns:r="http://schemas.openxmlformats.org/officeDocument/2006/relationships" xmlns:p="http://schemas.openxmlformats.org/presentationml/2006/main">
   <p:cSld>
     <p:bg>
       <p:bgPr>
@@ -3106,7 +3149,14 @@
         <p:cNvGrpSpPr/>
         <p:nvPr/>
       </p:nvGrpSpPr>
-      <p:grpSpPr/>
+      <p:grpSpPr>
+        <a:xfrm>
+          <a:off x="0" y="0"/>
+          <a:ext cx="0" cy="0"/>
+          <a:chOff x="0" y="0"/>
+          <a:chExt cx="0" cy="0"/>
+        </a:xfrm>
+      </p:grpSpPr>
       <p:sp>
         <p:nvSpPr>
           <p:cNvPr id="2" name="Rectangle 1"/>
@@ -3147,6 +3197,7 @@
           <a:lstStyle/>
           <a:p>
             <a:pPr algn="ctr"/>
+            <a:endParaRPr/>
           </a:p>
         </p:txBody>
       </p:sp>
@@ -3292,6 +3343,7 @@
           <a:lstStyle/>
           <a:p>
             <a:pPr algn="ctr"/>
+            <a:endParaRPr/>
           </a:p>
         </p:txBody>
       </p:sp>
@@ -3403,6 +3455,7 @@
           <a:lstStyle/>
           <a:p>
             <a:pPr algn="ctr"/>
+            <a:endParaRPr/>
           </a:p>
         </p:txBody>
       </p:sp>
@@ -3514,6 +3567,7 @@
           <a:lstStyle/>
           <a:p>
             <a:pPr algn="ctr"/>
+            <a:endParaRPr/>
           </a:p>
         </p:txBody>
       </p:sp>
@@ -3625,6 +3679,7 @@
           <a:lstStyle/>
           <a:p>
             <a:pPr algn="ctr"/>
+            <a:endParaRPr/>
           </a:p>
         </p:txBody>
       </p:sp>
@@ -3739,7 +3794,7 @@
 </file>
 
 <file path=ppt/slides/slide10.xml><?xml version="1.0" encoding="utf-8"?>
-<p:sld xmlns:a="http://schemas.openxmlformats.org/drawingml/2006/main" xmlns:p="http://schemas.openxmlformats.org/presentationml/2006/main" xmlns:r="http://schemas.openxmlformats.org/officeDocument/2006/relationships">
+<p:sld xmlns:a="http://schemas.openxmlformats.org/drawingml/2006/main" xmlns:r="http://schemas.openxmlformats.org/officeDocument/2006/relationships" xmlns:p="http://schemas.openxmlformats.org/presentationml/2006/main">
   <p:cSld>
     <p:bg>
       <p:bgPr>
@@ -3755,7 +3810,14 @@
         <p:cNvGrpSpPr/>
         <p:nvPr/>
       </p:nvGrpSpPr>
-      <p:grpSpPr/>
+      <p:grpSpPr>
+        <a:xfrm>
+          <a:off x="0" y="0"/>
+          <a:ext cx="0" cy="0"/>
+          <a:chOff x="0" y="0"/>
+          <a:chExt cx="0" cy="0"/>
+        </a:xfrm>
+      </p:grpSpPr>
       <p:sp>
         <p:nvSpPr>
           <p:cNvPr id="2" name="Rectangle 1"/>
@@ -3796,6 +3858,7 @@
           <a:lstStyle/>
           <a:p>
             <a:pPr algn="ctr"/>
+            <a:endParaRPr/>
           </a:p>
         </p:txBody>
       </p:sp>
@@ -3920,17 +3983,53 @@
                 <a:tableStyleId>{5C22544A-7EE6-4342-B048-85BDC9FD1C3A}</a:tableStyleId>
               </a:tblPr>
               <a:tblGrid>
-                <a:gridCol w="1905000"/>
-                <a:gridCol w="1905000"/>
-                <a:gridCol w="1905000"/>
-                <a:gridCol w="1905000"/>
-                <a:gridCol w="1905000"/>
-                <a:gridCol w="1905000"/>
+                <a:gridCol w="1905000">
+                  <a:extLst>
+                    <a:ext uri="{9D8B030D-6E8A-4147-A177-3AD203B41FA5}">
+                      <a16:colId xmlns:a16="http://schemas.microsoft.com/office/drawing/2014/main" val="20000"/>
+                    </a:ext>
+                  </a:extLst>
+                </a:gridCol>
+                <a:gridCol w="1905000">
+                  <a:extLst>
+                    <a:ext uri="{9D8B030D-6E8A-4147-A177-3AD203B41FA5}">
+                      <a16:colId xmlns:a16="http://schemas.microsoft.com/office/drawing/2014/main" val="20001"/>
+                    </a:ext>
+                  </a:extLst>
+                </a:gridCol>
+                <a:gridCol w="1905000">
+                  <a:extLst>
+                    <a:ext uri="{9D8B030D-6E8A-4147-A177-3AD203B41FA5}">
+                      <a16:colId xmlns:a16="http://schemas.microsoft.com/office/drawing/2014/main" val="20002"/>
+                    </a:ext>
+                  </a:extLst>
+                </a:gridCol>
+                <a:gridCol w="1905000">
+                  <a:extLst>
+                    <a:ext uri="{9D8B030D-6E8A-4147-A177-3AD203B41FA5}">
+                      <a16:colId xmlns:a16="http://schemas.microsoft.com/office/drawing/2014/main" val="20003"/>
+                    </a:ext>
+                  </a:extLst>
+                </a:gridCol>
+                <a:gridCol w="1905000">
+                  <a:extLst>
+                    <a:ext uri="{9D8B030D-6E8A-4147-A177-3AD203B41FA5}">
+                      <a16:colId xmlns:a16="http://schemas.microsoft.com/office/drawing/2014/main" val="20004"/>
+                    </a:ext>
+                  </a:extLst>
+                </a:gridCol>
+                <a:gridCol w="1905000">
+                  <a:extLst>
+                    <a:ext uri="{9D8B030D-6E8A-4147-A177-3AD203B41FA5}">
+                      <a16:colId xmlns:a16="http://schemas.microsoft.com/office/drawing/2014/main" val="20005"/>
+                    </a:ext>
+                  </a:extLst>
+                </a:gridCol>
               </a:tblGrid>
               <a:tr h="411480">
                 <a:tc>
                   <a:txBody>
-                    <a:bodyPr wrap="square"/>
+                    <a:bodyPr/>
                     <a:lstStyle/>
                     <a:p>
                       <a:pPr algn="ctr"/>
@@ -3952,7 +4051,7 @@
                 </a:tc>
                 <a:tc>
                   <a:txBody>
-                    <a:bodyPr wrap="square"/>
+                    <a:bodyPr/>
                     <a:lstStyle/>
                     <a:p>
                       <a:pPr algn="ctr"/>
@@ -3974,7 +4073,7 @@
                 </a:tc>
                 <a:tc>
                   <a:txBody>
-                    <a:bodyPr wrap="square"/>
+                    <a:bodyPr/>
                     <a:lstStyle/>
                     <a:p>
                       <a:pPr algn="ctr"/>
@@ -3996,7 +4095,7 @@
                 </a:tc>
                 <a:tc>
                   <a:txBody>
-                    <a:bodyPr wrap="square"/>
+                    <a:bodyPr/>
                     <a:lstStyle/>
                     <a:p>
                       <a:pPr algn="ctr"/>
@@ -4018,7 +4117,7 @@
                 </a:tc>
                 <a:tc>
                   <a:txBody>
-                    <a:bodyPr wrap="square"/>
+                    <a:bodyPr/>
                     <a:lstStyle/>
                     <a:p>
                       <a:pPr algn="ctr"/>
@@ -4040,7 +4139,7 @@
                 </a:tc>
                 <a:tc>
                   <a:txBody>
-                    <a:bodyPr wrap="square"/>
+                    <a:bodyPr/>
                     <a:lstStyle/>
                     <a:p>
                       <a:pPr algn="ctr"/>
@@ -4060,11 +4159,16 @@
                     </a:solidFill>
                   </a:tcPr>
                 </a:tc>
+                <a:extLst>
+                  <a:ext uri="{0D108BD9-81ED-4DB2-BD59-A6C34878D82A}">
+                    <a16:rowId xmlns:a16="http://schemas.microsoft.com/office/drawing/2014/main" val="10000"/>
+                  </a:ext>
+                </a:extLst>
               </a:tr>
               <a:tr h="411480">
                 <a:tc>
                   <a:txBody>
-                    <a:bodyPr wrap="square"/>
+                    <a:bodyPr/>
                     <a:lstStyle/>
                     <a:p>
                       <a:pPr algn="ctr"/>
@@ -4086,7 +4190,7 @@
                 </a:tc>
                 <a:tc>
                   <a:txBody>
-                    <a:bodyPr wrap="square"/>
+                    <a:bodyPr/>
                     <a:lstStyle/>
                     <a:p>
                       <a:pPr algn="ctr"/>
@@ -4108,7 +4212,7 @@
                 </a:tc>
                 <a:tc>
                   <a:txBody>
-                    <a:bodyPr wrap="square"/>
+                    <a:bodyPr/>
                     <a:lstStyle/>
                     <a:p>
                       <a:pPr algn="ctr"/>
@@ -4130,7 +4234,7 @@
                 </a:tc>
                 <a:tc>
                   <a:txBody>
-                    <a:bodyPr wrap="square"/>
+                    <a:bodyPr/>
                     <a:lstStyle/>
                     <a:p>
                       <a:pPr algn="ctr"/>
@@ -4152,7 +4256,7 @@
                 </a:tc>
                 <a:tc>
                   <a:txBody>
-                    <a:bodyPr wrap="square"/>
+                    <a:bodyPr/>
                     <a:lstStyle/>
                     <a:p>
                       <a:pPr algn="ctr"/>
@@ -4174,7 +4278,7 @@
                 </a:tc>
                 <a:tc>
                   <a:txBody>
-                    <a:bodyPr wrap="square"/>
+                    <a:bodyPr/>
                     <a:lstStyle/>
                     <a:p>
                       <a:pPr algn="ctr"/>
@@ -4194,11 +4298,16 @@
                     </a:solidFill>
                   </a:tcPr>
                 </a:tc>
+                <a:extLst>
+                  <a:ext uri="{0D108BD9-81ED-4DB2-BD59-A6C34878D82A}">
+                    <a16:rowId xmlns:a16="http://schemas.microsoft.com/office/drawing/2014/main" val="10001"/>
+                  </a:ext>
+                </a:extLst>
               </a:tr>
               <a:tr h="411480">
                 <a:tc>
                   <a:txBody>
-                    <a:bodyPr wrap="square"/>
+                    <a:bodyPr/>
                     <a:lstStyle/>
                     <a:p>
                       <a:pPr algn="ctr"/>
@@ -4220,7 +4329,7 @@
                 </a:tc>
                 <a:tc>
                   <a:txBody>
-                    <a:bodyPr wrap="square"/>
+                    <a:bodyPr/>
                     <a:lstStyle/>
                     <a:p>
                       <a:pPr algn="ctr"/>
@@ -4242,7 +4351,7 @@
                 </a:tc>
                 <a:tc>
                   <a:txBody>
-                    <a:bodyPr wrap="square"/>
+                    <a:bodyPr/>
                     <a:lstStyle/>
                     <a:p>
                       <a:pPr algn="ctr"/>
@@ -4264,7 +4373,7 @@
                 </a:tc>
                 <a:tc>
                   <a:txBody>
-                    <a:bodyPr wrap="square"/>
+                    <a:bodyPr/>
                     <a:lstStyle/>
                     <a:p>
                       <a:pPr algn="ctr"/>
@@ -4286,7 +4395,7 @@
                 </a:tc>
                 <a:tc>
                   <a:txBody>
-                    <a:bodyPr wrap="square"/>
+                    <a:bodyPr/>
                     <a:lstStyle/>
                     <a:p>
                       <a:pPr algn="ctr"/>
@@ -4308,7 +4417,7 @@
                 </a:tc>
                 <a:tc>
                   <a:txBody>
-                    <a:bodyPr wrap="square"/>
+                    <a:bodyPr/>
                     <a:lstStyle/>
                     <a:p>
                       <a:pPr algn="ctr"/>
@@ -4328,11 +4437,16 @@
                     </a:solidFill>
                   </a:tcPr>
                 </a:tc>
+                <a:extLst>
+                  <a:ext uri="{0D108BD9-81ED-4DB2-BD59-A6C34878D82A}">
+                    <a16:rowId xmlns:a16="http://schemas.microsoft.com/office/drawing/2014/main" val="10002"/>
+                  </a:ext>
+                </a:extLst>
               </a:tr>
               <a:tr h="411480">
                 <a:tc>
                   <a:txBody>
-                    <a:bodyPr wrap="square"/>
+                    <a:bodyPr/>
                     <a:lstStyle/>
                     <a:p>
                       <a:pPr algn="ctr"/>
@@ -4354,7 +4468,7 @@
                 </a:tc>
                 <a:tc>
                   <a:txBody>
-                    <a:bodyPr wrap="square"/>
+                    <a:bodyPr/>
                     <a:lstStyle/>
                     <a:p>
                       <a:pPr algn="ctr"/>
@@ -4376,7 +4490,7 @@
                 </a:tc>
                 <a:tc>
                   <a:txBody>
-                    <a:bodyPr wrap="square"/>
+                    <a:bodyPr/>
                     <a:lstStyle/>
                     <a:p>
                       <a:pPr algn="ctr"/>
@@ -4398,7 +4512,7 @@
                 </a:tc>
                 <a:tc>
                   <a:txBody>
-                    <a:bodyPr wrap="square"/>
+                    <a:bodyPr/>
                     <a:lstStyle/>
                     <a:p>
                       <a:pPr algn="ctr"/>
@@ -4420,7 +4534,7 @@
                 </a:tc>
                 <a:tc>
                   <a:txBody>
-                    <a:bodyPr wrap="square"/>
+                    <a:bodyPr/>
                     <a:lstStyle/>
                     <a:p>
                       <a:pPr algn="ctr"/>
@@ -4442,7 +4556,7 @@
                 </a:tc>
                 <a:tc>
                   <a:txBody>
-                    <a:bodyPr wrap="square"/>
+                    <a:bodyPr/>
                     <a:lstStyle/>
                     <a:p>
                       <a:pPr algn="ctr"/>
@@ -4462,6 +4576,11 @@
                     </a:solidFill>
                   </a:tcPr>
                 </a:tc>
+                <a:extLst>
+                  <a:ext uri="{0D108BD9-81ED-4DB2-BD59-A6C34878D82A}">
+                    <a16:rowId xmlns:a16="http://schemas.microsoft.com/office/drawing/2014/main" val="10003"/>
+                  </a:ext>
+                </a:extLst>
               </a:tr>
             </a:tbl>
           </a:graphicData>
@@ -4541,6 +4660,7 @@
           <a:lstStyle/>
           <a:p>
             <a:pPr algn="ctr"/>
+            <a:endParaRPr/>
           </a:p>
         </p:txBody>
       </p:sp>
@@ -4652,6 +4772,7 @@
           <a:lstStyle/>
           <a:p>
             <a:pPr algn="ctr"/>
+            <a:endParaRPr/>
           </a:p>
         </p:txBody>
       </p:sp>
@@ -4763,6 +4884,7 @@
           <a:lstStyle/>
           <a:p>
             <a:pPr algn="ctr"/>
+            <a:endParaRPr/>
           </a:p>
         </p:txBody>
       </p:sp>
@@ -4874,6 +4996,7 @@
           <a:lstStyle/>
           <a:p>
             <a:pPr algn="ctr"/>
+            <a:endParaRPr/>
           </a:p>
         </p:txBody>
       </p:sp>
@@ -4921,7 +5044,7 @@
 </file>
 
 <file path=ppt/slides/slide11.xml><?xml version="1.0" encoding="utf-8"?>
-<p:sld xmlns:a="http://schemas.openxmlformats.org/drawingml/2006/main" xmlns:p="http://schemas.openxmlformats.org/presentationml/2006/main" xmlns:r="http://schemas.openxmlformats.org/officeDocument/2006/relationships">
+<p:sld xmlns:a="http://schemas.openxmlformats.org/drawingml/2006/main" xmlns:r="http://schemas.openxmlformats.org/officeDocument/2006/relationships" xmlns:p="http://schemas.openxmlformats.org/presentationml/2006/main">
   <p:cSld>
     <p:bg>
       <p:bgPr>
@@ -4937,7 +5060,14 @@
         <p:cNvGrpSpPr/>
         <p:nvPr/>
       </p:nvGrpSpPr>
-      <p:grpSpPr/>
+      <p:grpSpPr>
+        <a:xfrm>
+          <a:off x="0" y="0"/>
+          <a:ext cx="0" cy="0"/>
+          <a:chOff x="0" y="0"/>
+          <a:chExt cx="0" cy="0"/>
+        </a:xfrm>
+      </p:grpSpPr>
       <p:sp>
         <p:nvSpPr>
           <p:cNvPr id="2" name="Rectangle 1"/>
@@ -4978,6 +5108,7 @@
           <a:lstStyle/>
           <a:p>
             <a:pPr algn="ctr"/>
+            <a:endParaRPr/>
           </a:p>
         </p:txBody>
       </p:sp>
@@ -5068,14 +5199,32 @@
                 <a:tableStyleId>{5C22544A-7EE6-4342-B048-85BDC9FD1C3A}</a:tableStyleId>
               </a:tblPr>
               <a:tblGrid>
-                <a:gridCol w="3810000"/>
-                <a:gridCol w="3810000"/>
-                <a:gridCol w="3810000"/>
+                <a:gridCol w="3810000">
+                  <a:extLst>
+                    <a:ext uri="{9D8B030D-6E8A-4147-A177-3AD203B41FA5}">
+                      <a16:colId xmlns:a16="http://schemas.microsoft.com/office/drawing/2014/main" val="20000"/>
+                    </a:ext>
+                  </a:extLst>
+                </a:gridCol>
+                <a:gridCol w="3810000">
+                  <a:extLst>
+                    <a:ext uri="{9D8B030D-6E8A-4147-A177-3AD203B41FA5}">
+                      <a16:colId xmlns:a16="http://schemas.microsoft.com/office/drawing/2014/main" val="20001"/>
+                    </a:ext>
+                  </a:extLst>
+                </a:gridCol>
+                <a:gridCol w="3810000">
+                  <a:extLst>
+                    <a:ext uri="{9D8B030D-6E8A-4147-A177-3AD203B41FA5}">
+                      <a16:colId xmlns:a16="http://schemas.microsoft.com/office/drawing/2014/main" val="20002"/>
+                    </a:ext>
+                  </a:extLst>
+                </a:gridCol>
               </a:tblGrid>
               <a:tr h="533400">
                 <a:tc>
                   <a:txBody>
-                    <a:bodyPr wrap="square"/>
+                    <a:bodyPr/>
                     <a:lstStyle/>
                     <a:p>
                       <a:pPr algn="ctr"/>
@@ -5097,7 +5246,7 @@
                 </a:tc>
                 <a:tc>
                   <a:txBody>
-                    <a:bodyPr wrap="square"/>
+                    <a:bodyPr/>
                     <a:lstStyle/>
                     <a:p>
                       <a:pPr algn="ctr"/>
@@ -5119,7 +5268,7 @@
                 </a:tc>
                 <a:tc>
                   <a:txBody>
-                    <a:bodyPr wrap="square"/>
+                    <a:bodyPr/>
                     <a:lstStyle/>
                     <a:p>
                       <a:pPr algn="ctr"/>
@@ -5139,11 +5288,16 @@
                     </a:solidFill>
                   </a:tcPr>
                 </a:tc>
+                <a:extLst>
+                  <a:ext uri="{0D108BD9-81ED-4DB2-BD59-A6C34878D82A}">
+                    <a16:rowId xmlns:a16="http://schemas.microsoft.com/office/drawing/2014/main" val="10000"/>
+                  </a:ext>
+                </a:extLst>
               </a:tr>
               <a:tr h="533400">
                 <a:tc>
                   <a:txBody>
-                    <a:bodyPr wrap="square"/>
+                    <a:bodyPr/>
                     <a:lstStyle/>
                     <a:p>
                       <a:pPr algn="ctr"/>
@@ -5165,7 +5319,7 @@
                 </a:tc>
                 <a:tc>
                   <a:txBody>
-                    <a:bodyPr wrap="square"/>
+                    <a:bodyPr/>
                     <a:lstStyle/>
                     <a:p>
                       <a:pPr algn="ctr"/>
@@ -5187,7 +5341,7 @@
                 </a:tc>
                 <a:tc>
                   <a:txBody>
-                    <a:bodyPr wrap="square"/>
+                    <a:bodyPr/>
                     <a:lstStyle/>
                     <a:p>
                       <a:pPr algn="ctr"/>
@@ -5207,11 +5361,16 @@
                     </a:solidFill>
                   </a:tcPr>
                 </a:tc>
+                <a:extLst>
+                  <a:ext uri="{0D108BD9-81ED-4DB2-BD59-A6C34878D82A}">
+                    <a16:rowId xmlns:a16="http://schemas.microsoft.com/office/drawing/2014/main" val="10001"/>
+                  </a:ext>
+                </a:extLst>
               </a:tr>
               <a:tr h="533400">
                 <a:tc>
                   <a:txBody>
-                    <a:bodyPr wrap="square"/>
+                    <a:bodyPr/>
                     <a:lstStyle/>
                     <a:p>
                       <a:pPr algn="ctr"/>
@@ -5233,7 +5392,7 @@
                 </a:tc>
                 <a:tc>
                   <a:txBody>
-                    <a:bodyPr wrap="square"/>
+                    <a:bodyPr/>
                     <a:lstStyle/>
                     <a:p>
                       <a:pPr algn="ctr"/>
@@ -5255,7 +5414,7 @@
                 </a:tc>
                 <a:tc>
                   <a:txBody>
-                    <a:bodyPr wrap="square"/>
+                    <a:bodyPr/>
                     <a:lstStyle/>
                     <a:p>
                       <a:pPr algn="ctr"/>
@@ -5275,11 +5434,16 @@
                     </a:solidFill>
                   </a:tcPr>
                 </a:tc>
+                <a:extLst>
+                  <a:ext uri="{0D108BD9-81ED-4DB2-BD59-A6C34878D82A}">
+                    <a16:rowId xmlns:a16="http://schemas.microsoft.com/office/drawing/2014/main" val="10002"/>
+                  </a:ext>
+                </a:extLst>
               </a:tr>
               <a:tr h="533400">
                 <a:tc>
                   <a:txBody>
-                    <a:bodyPr wrap="square"/>
+                    <a:bodyPr/>
                     <a:lstStyle/>
                     <a:p>
                       <a:pPr algn="ctr"/>
@@ -5301,7 +5465,7 @@
                 </a:tc>
                 <a:tc>
                   <a:txBody>
-                    <a:bodyPr wrap="square"/>
+                    <a:bodyPr/>
                     <a:lstStyle/>
                     <a:p>
                       <a:pPr algn="ctr"/>
@@ -5323,7 +5487,7 @@
                 </a:tc>
                 <a:tc>
                   <a:txBody>
-                    <a:bodyPr wrap="square"/>
+                    <a:bodyPr/>
                     <a:lstStyle/>
                     <a:p>
                       <a:pPr algn="ctr"/>
@@ -5343,11 +5507,16 @@
                     </a:solidFill>
                   </a:tcPr>
                 </a:tc>
+                <a:extLst>
+                  <a:ext uri="{0D108BD9-81ED-4DB2-BD59-A6C34878D82A}">
+                    <a16:rowId xmlns:a16="http://schemas.microsoft.com/office/drawing/2014/main" val="10003"/>
+                  </a:ext>
+                </a:extLst>
               </a:tr>
               <a:tr h="533400">
                 <a:tc>
                   <a:txBody>
-                    <a:bodyPr wrap="square"/>
+                    <a:bodyPr/>
                     <a:lstStyle/>
                     <a:p>
                       <a:pPr algn="ctr"/>
@@ -5369,7 +5538,7 @@
                 </a:tc>
                 <a:tc>
                   <a:txBody>
-                    <a:bodyPr wrap="square"/>
+                    <a:bodyPr/>
                     <a:lstStyle/>
                     <a:p>
                       <a:pPr algn="ctr"/>
@@ -5391,7 +5560,7 @@
                 </a:tc>
                 <a:tc>
                   <a:txBody>
-                    <a:bodyPr wrap="square"/>
+                    <a:bodyPr/>
                     <a:lstStyle/>
                     <a:p>
                       <a:pPr algn="ctr"/>
@@ -5411,11 +5580,16 @@
                     </a:solidFill>
                   </a:tcPr>
                 </a:tc>
+                <a:extLst>
+                  <a:ext uri="{0D108BD9-81ED-4DB2-BD59-A6C34878D82A}">
+                    <a16:rowId xmlns:a16="http://schemas.microsoft.com/office/drawing/2014/main" val="10004"/>
+                  </a:ext>
+                </a:extLst>
               </a:tr>
               <a:tr h="533400">
                 <a:tc>
                   <a:txBody>
-                    <a:bodyPr wrap="square"/>
+                    <a:bodyPr/>
                     <a:lstStyle/>
                     <a:p>
                       <a:pPr algn="ctr"/>
@@ -5437,7 +5611,7 @@
                 </a:tc>
                 <a:tc>
                   <a:txBody>
-                    <a:bodyPr wrap="square"/>
+                    <a:bodyPr/>
                     <a:lstStyle/>
                     <a:p>
                       <a:pPr algn="ctr"/>
@@ -5459,7 +5633,7 @@
                 </a:tc>
                 <a:tc>
                   <a:txBody>
-                    <a:bodyPr wrap="square"/>
+                    <a:bodyPr/>
                     <a:lstStyle/>
                     <a:p>
                       <a:pPr algn="ctr"/>
@@ -5479,6 +5653,11 @@
                     </a:solidFill>
                   </a:tcPr>
                 </a:tc>
+                <a:extLst>
+                  <a:ext uri="{0D108BD9-81ED-4DB2-BD59-A6C34878D82A}">
+                    <a16:rowId xmlns:a16="http://schemas.microsoft.com/office/drawing/2014/main" val="10005"/>
+                  </a:ext>
+                </a:extLst>
               </a:tr>
             </a:tbl>
           </a:graphicData>
@@ -5524,6 +5703,7 @@
           <a:lstStyle/>
           <a:p>
             <a:pPr algn="ctr"/>
+            <a:endParaRPr/>
           </a:p>
         </p:txBody>
       </p:sp>
@@ -5570,7 +5750,7 @@
 </file>
 
 <file path=ppt/slides/slide12.xml><?xml version="1.0" encoding="utf-8"?>
-<p:sld xmlns:a="http://schemas.openxmlformats.org/drawingml/2006/main" xmlns:p="http://schemas.openxmlformats.org/presentationml/2006/main" xmlns:r="http://schemas.openxmlformats.org/officeDocument/2006/relationships">
+<p:sld xmlns:a="http://schemas.openxmlformats.org/drawingml/2006/main" xmlns:r="http://schemas.openxmlformats.org/officeDocument/2006/relationships" xmlns:p="http://schemas.openxmlformats.org/presentationml/2006/main">
   <p:cSld>
     <p:bg>
       <p:bgPr>
@@ -5586,7 +5766,14 @@
         <p:cNvGrpSpPr/>
         <p:nvPr/>
       </p:nvGrpSpPr>
-      <p:grpSpPr/>
+      <p:grpSpPr>
+        <a:xfrm>
+          <a:off x="0" y="0"/>
+          <a:ext cx="0" cy="0"/>
+          <a:chOff x="0" y="0"/>
+          <a:chExt cx="0" cy="0"/>
+        </a:xfrm>
+      </p:grpSpPr>
       <p:sp>
         <p:nvSpPr>
           <p:cNvPr id="2" name="Rectangle 1"/>
@@ -5627,6 +5814,7 @@
           <a:lstStyle/>
           <a:p>
             <a:pPr algn="ctr"/>
+            <a:endParaRPr/>
           </a:p>
         </p:txBody>
       </p:sp>
@@ -5796,6 +5984,7 @@
           <a:lstStyle/>
           <a:p>
             <a:pPr algn="ctr"/>
+            <a:endParaRPr/>
           </a:p>
         </p:txBody>
       </p:sp>
@@ -5907,6 +6096,7 @@
           <a:lstStyle/>
           <a:p>
             <a:pPr algn="ctr"/>
+            <a:endParaRPr/>
           </a:p>
         </p:txBody>
       </p:sp>
@@ -6018,6 +6208,7 @@
           <a:lstStyle/>
           <a:p>
             <a:pPr algn="ctr"/>
+            <a:endParaRPr/>
           </a:p>
         </p:txBody>
       </p:sp>
@@ -6129,6 +6320,7 @@
           <a:lstStyle/>
           <a:p>
             <a:pPr algn="ctr"/>
+            <a:endParaRPr/>
           </a:p>
         </p:txBody>
       </p:sp>
@@ -6240,6 +6432,7 @@
           <a:lstStyle/>
           <a:p>
             <a:pPr algn="ctr"/>
+            <a:endParaRPr/>
           </a:p>
         </p:txBody>
       </p:sp>
@@ -6351,6 +6544,7 @@
           <a:lstStyle/>
           <a:p>
             <a:pPr algn="ctr"/>
+            <a:endParaRPr/>
           </a:p>
         </p:txBody>
       </p:sp>
@@ -6397,7 +6591,7 @@
 </file>
 
 <file path=ppt/slides/slide2.xml><?xml version="1.0" encoding="utf-8"?>
-<p:sld xmlns:a="http://schemas.openxmlformats.org/drawingml/2006/main" xmlns:p="http://schemas.openxmlformats.org/presentationml/2006/main" xmlns:r="http://schemas.openxmlformats.org/officeDocument/2006/relationships">
+<p:sld xmlns:a="http://schemas.openxmlformats.org/drawingml/2006/main" xmlns:r="http://schemas.openxmlformats.org/officeDocument/2006/relationships" xmlns:p="http://schemas.openxmlformats.org/presentationml/2006/main">
   <p:cSld>
     <p:bg>
       <p:bgPr>
@@ -6413,7 +6607,14 @@
         <p:cNvGrpSpPr/>
         <p:nvPr/>
       </p:nvGrpSpPr>
-      <p:grpSpPr/>
+      <p:grpSpPr>
+        <a:xfrm>
+          <a:off x="0" y="0"/>
+          <a:ext cx="0" cy="0"/>
+          <a:chOff x="0" y="0"/>
+          <a:chExt cx="0" cy="0"/>
+        </a:xfrm>
+      </p:grpSpPr>
       <p:sp>
         <p:nvSpPr>
           <p:cNvPr id="2" name="Rectangle 1"/>
@@ -6454,6 +6655,7 @@
           <a:lstStyle/>
           <a:p>
             <a:pPr algn="ctr"/>
+            <a:endParaRPr/>
           </a:p>
         </p:txBody>
       </p:sp>
@@ -6565,6 +6767,7 @@
           <a:lstStyle/>
           <a:p>
             <a:pPr algn="ctr"/>
+            <a:endParaRPr/>
           </a:p>
         </p:txBody>
       </p:sp>
@@ -6681,6 +6884,7 @@
           <a:lstStyle/>
           <a:p>
             <a:pPr algn="ctr"/>
+            <a:endParaRPr/>
           </a:p>
         </p:txBody>
       </p:sp>
@@ -6727,7 +6931,7 @@
         <p:spPr>
           <a:xfrm>
             <a:off x="6126480" y="1645920"/>
-            <a:ext cx="5669280" cy="502920"/>
+            <a:ext cx="4821606" cy="492443"/>
           </a:xfrm>
           <a:prstGeom prst="rect">
             <a:avLst/>
@@ -6742,14 +6946,52 @@
           <a:p>
             <a:pPr algn="l"/>
             <a:r>
-              <a:rPr sz="1300" b="0" i="0">
+              <a:rPr sz="1300" b="0" i="0" dirty="0">
                 <a:solidFill>
                   <a:srgbClr val="FFFFFF"/>
                 </a:solidFill>
               </a:rPr>
-              <a:t>Classify network connection records
-(41 features) as Normal or Attack,
-identifying attack category.</a:t>
+              <a:t>Classify network connection record</a:t>
+            </a:r>
+            <a:r>
+              <a:rPr lang="en-IN" sz="1300" b="0" i="0" dirty="0">
+                <a:solidFill>
+                  <a:srgbClr val="FFFFFF"/>
+                </a:solidFill>
+              </a:rPr>
+              <a:t>s</a:t>
+            </a:r>
+            <a:r>
+              <a:rPr lang="en-IN" sz="1300" dirty="0">
+                <a:solidFill>
+                  <a:srgbClr val="FFFFFF"/>
+                </a:solidFill>
+              </a:rPr>
+              <a:t> </a:t>
+            </a:r>
+            <a:r>
+              <a:rPr sz="1300" b="0" i="0" dirty="0">
+                <a:solidFill>
+                  <a:srgbClr val="FFFFFF"/>
+                </a:solidFill>
+              </a:rPr>
+              <a:t>(41 features) as Normal or Attack,</a:t>
+            </a:r>
+            <a:r>
+              <a:rPr lang="en-US" sz="1300" b="0" i="0" dirty="0">
+                <a:solidFill>
+                  <a:srgbClr val="FFFFFF"/>
+                </a:solidFill>
+              </a:rPr>
+              <a:t> </a:t>
+            </a:r>
+            <a:r>
+              <a:rPr sz="1300" b="0" i="0" dirty="0">
+                <a:solidFill>
+                  <a:srgbClr val="FFFFFF"/>
+                </a:solidFill>
+              </a:rPr>
+              <a:t>identifying attack category.</a:t>
             </a:r>
           </a:p>
         </p:txBody>
@@ -6807,14 +7049,32 @@
                 <a:tableStyleId>{5C22544A-7EE6-4342-B048-85BDC9FD1C3A}</a:tableStyleId>
               </a:tblPr>
               <a:tblGrid>
-                <a:gridCol w="1950720"/>
-                <a:gridCol w="1950720"/>
-                <a:gridCol w="1950720"/>
+                <a:gridCol w="1950720">
+                  <a:extLst>
+                    <a:ext uri="{9D8B030D-6E8A-4147-A177-3AD203B41FA5}">
+                      <a16:colId xmlns:a16="http://schemas.microsoft.com/office/drawing/2014/main" val="20000"/>
+                    </a:ext>
+                  </a:extLst>
+                </a:gridCol>
+                <a:gridCol w="1950720">
+                  <a:extLst>
+                    <a:ext uri="{9D8B030D-6E8A-4147-A177-3AD203B41FA5}">
+                      <a16:colId xmlns:a16="http://schemas.microsoft.com/office/drawing/2014/main" val="20001"/>
+                    </a:ext>
+                  </a:extLst>
+                </a:gridCol>
+                <a:gridCol w="1950720">
+                  <a:extLst>
+                    <a:ext uri="{9D8B030D-6E8A-4147-A177-3AD203B41FA5}">
+                      <a16:colId xmlns:a16="http://schemas.microsoft.com/office/drawing/2014/main" val="20002"/>
+                    </a:ext>
+                  </a:extLst>
+                </a:gridCol>
               </a:tblGrid>
               <a:tr h="384048">
                 <a:tc>
                   <a:txBody>
-                    <a:bodyPr wrap="square"/>
+                    <a:bodyPr/>
                     <a:lstStyle/>
                     <a:p>
                       <a:pPr algn="ctr"/>
@@ -6836,7 +7096,7 @@
                 </a:tc>
                 <a:tc>
                   <a:txBody>
-                    <a:bodyPr wrap="square"/>
+                    <a:bodyPr/>
                     <a:lstStyle/>
                     <a:p>
                       <a:pPr algn="ctr"/>
@@ -6858,7 +7118,7 @@
                 </a:tc>
                 <a:tc>
                   <a:txBody>
-                    <a:bodyPr wrap="square"/>
+                    <a:bodyPr/>
                     <a:lstStyle/>
                     <a:p>
                       <a:pPr algn="ctr"/>
@@ -6878,11 +7138,16 @@
                     </a:solidFill>
                   </a:tcPr>
                 </a:tc>
+                <a:extLst>
+                  <a:ext uri="{0D108BD9-81ED-4DB2-BD59-A6C34878D82A}">
+                    <a16:rowId xmlns:a16="http://schemas.microsoft.com/office/drawing/2014/main" val="10000"/>
+                  </a:ext>
+                </a:extLst>
               </a:tr>
               <a:tr h="384048">
                 <a:tc>
                   <a:txBody>
-                    <a:bodyPr wrap="square"/>
+                    <a:bodyPr/>
                     <a:lstStyle/>
                     <a:p>
                       <a:pPr algn="ctr"/>
@@ -6904,7 +7169,7 @@
                 </a:tc>
                 <a:tc>
                   <a:txBody>
-                    <a:bodyPr wrap="square"/>
+                    <a:bodyPr/>
                     <a:lstStyle/>
                     <a:p>
                       <a:pPr algn="ctr"/>
@@ -6926,7 +7191,7 @@
                 </a:tc>
                 <a:tc>
                   <a:txBody>
-                    <a:bodyPr wrap="square"/>
+                    <a:bodyPr/>
                     <a:lstStyle/>
                     <a:p>
                       <a:pPr algn="ctr"/>
@@ -6946,11 +7211,16 @@
                     </a:solidFill>
                   </a:tcPr>
                 </a:tc>
+                <a:extLst>
+                  <a:ext uri="{0D108BD9-81ED-4DB2-BD59-A6C34878D82A}">
+                    <a16:rowId xmlns:a16="http://schemas.microsoft.com/office/drawing/2014/main" val="10001"/>
+                  </a:ext>
+                </a:extLst>
               </a:tr>
               <a:tr h="384048">
                 <a:tc>
                   <a:txBody>
-                    <a:bodyPr wrap="square"/>
+                    <a:bodyPr/>
                     <a:lstStyle/>
                     <a:p>
                       <a:pPr algn="ctr"/>
@@ -6972,7 +7242,7 @@
                 </a:tc>
                 <a:tc>
                   <a:txBody>
-                    <a:bodyPr wrap="square"/>
+                    <a:bodyPr/>
                     <a:lstStyle/>
                     <a:p>
                       <a:pPr algn="ctr"/>
@@ -6994,7 +7264,7 @@
                 </a:tc>
                 <a:tc>
                   <a:txBody>
-                    <a:bodyPr wrap="square"/>
+                    <a:bodyPr/>
                     <a:lstStyle/>
                     <a:p>
                       <a:pPr algn="ctr"/>
@@ -7014,11 +7284,16 @@
                     </a:solidFill>
                   </a:tcPr>
                 </a:tc>
+                <a:extLst>
+                  <a:ext uri="{0D108BD9-81ED-4DB2-BD59-A6C34878D82A}">
+                    <a16:rowId xmlns:a16="http://schemas.microsoft.com/office/drawing/2014/main" val="10002"/>
+                  </a:ext>
+                </a:extLst>
               </a:tr>
               <a:tr h="384048">
                 <a:tc>
                   <a:txBody>
-                    <a:bodyPr wrap="square"/>
+                    <a:bodyPr/>
                     <a:lstStyle/>
                     <a:p>
                       <a:pPr algn="ctr"/>
@@ -7040,7 +7315,7 @@
                 </a:tc>
                 <a:tc>
                   <a:txBody>
-                    <a:bodyPr wrap="square"/>
+                    <a:bodyPr/>
                     <a:lstStyle/>
                     <a:p>
                       <a:pPr algn="ctr"/>
@@ -7062,7 +7337,7 @@
                 </a:tc>
                 <a:tc>
                   <a:txBody>
-                    <a:bodyPr wrap="square"/>
+                    <a:bodyPr/>
                     <a:lstStyle/>
                     <a:p>
                       <a:pPr algn="ctr"/>
@@ -7082,11 +7357,16 @@
                     </a:solidFill>
                   </a:tcPr>
                 </a:tc>
+                <a:extLst>
+                  <a:ext uri="{0D108BD9-81ED-4DB2-BD59-A6C34878D82A}">
+                    <a16:rowId xmlns:a16="http://schemas.microsoft.com/office/drawing/2014/main" val="10003"/>
+                  </a:ext>
+                </a:extLst>
               </a:tr>
               <a:tr h="384048">
                 <a:tc>
                   <a:txBody>
-                    <a:bodyPr wrap="square"/>
+                    <a:bodyPr/>
                     <a:lstStyle/>
                     <a:p>
                       <a:pPr algn="ctr"/>
@@ -7108,7 +7388,7 @@
                 </a:tc>
                 <a:tc>
                   <a:txBody>
-                    <a:bodyPr wrap="square"/>
+                    <a:bodyPr/>
                     <a:lstStyle/>
                     <a:p>
                       <a:pPr algn="ctr"/>
@@ -7130,7 +7410,7 @@
                 </a:tc>
                 <a:tc>
                   <a:txBody>
-                    <a:bodyPr wrap="square"/>
+                    <a:bodyPr/>
                     <a:lstStyle/>
                     <a:p>
                       <a:pPr algn="ctr"/>
@@ -7150,6 +7430,11 @@
                     </a:solidFill>
                   </a:tcPr>
                 </a:tc>
+                <a:extLst>
+                  <a:ext uri="{0D108BD9-81ED-4DB2-BD59-A6C34878D82A}">
+                    <a16:rowId xmlns:a16="http://schemas.microsoft.com/office/drawing/2014/main" val="10004"/>
+                  </a:ext>
+                </a:extLst>
               </a:tr>
             </a:tbl>
           </a:graphicData>
@@ -7164,7 +7449,7 @@
 </file>
 
 <file path=ppt/slides/slide3.xml><?xml version="1.0" encoding="utf-8"?>
-<p:sld xmlns:a="http://schemas.openxmlformats.org/drawingml/2006/main" xmlns:p="http://schemas.openxmlformats.org/presentationml/2006/main" xmlns:r="http://schemas.openxmlformats.org/officeDocument/2006/relationships">
+<p:sld xmlns:a="http://schemas.openxmlformats.org/drawingml/2006/main" xmlns:r="http://schemas.openxmlformats.org/officeDocument/2006/relationships" xmlns:p="http://schemas.openxmlformats.org/presentationml/2006/main">
   <p:cSld>
     <p:bg>
       <p:bgPr>
@@ -7180,7 +7465,14 @@
         <p:cNvGrpSpPr/>
         <p:nvPr/>
       </p:nvGrpSpPr>
-      <p:grpSpPr/>
+      <p:grpSpPr>
+        <a:xfrm>
+          <a:off x="0" y="0"/>
+          <a:ext cx="0" cy="0"/>
+          <a:chOff x="0" y="0"/>
+          <a:chExt cx="0" cy="0"/>
+        </a:xfrm>
+      </p:grpSpPr>
       <p:sp>
         <p:nvSpPr>
           <p:cNvPr id="2" name="Rectangle 1"/>
@@ -7221,6 +7513,7 @@
           <a:lstStyle/>
           <a:p>
             <a:pPr algn="ctr"/>
+            <a:endParaRPr/>
           </a:p>
         </p:txBody>
       </p:sp>
@@ -7311,13 +7604,25 @@
                 <a:tableStyleId>{5C22544A-7EE6-4342-B048-85BDC9FD1C3A}</a:tableStyleId>
               </a:tblPr>
               <a:tblGrid>
-                <a:gridCol w="2834640"/>
-                <a:gridCol w="2834640"/>
+                <a:gridCol w="2834640">
+                  <a:extLst>
+                    <a:ext uri="{9D8B030D-6E8A-4147-A177-3AD203B41FA5}">
+                      <a16:colId xmlns:a16="http://schemas.microsoft.com/office/drawing/2014/main" val="20000"/>
+                    </a:ext>
+                  </a:extLst>
+                </a:gridCol>
+                <a:gridCol w="2834640">
+                  <a:extLst>
+                    <a:ext uri="{9D8B030D-6E8A-4147-A177-3AD203B41FA5}">
+                      <a16:colId xmlns:a16="http://schemas.microsoft.com/office/drawing/2014/main" val="20001"/>
+                    </a:ext>
+                  </a:extLst>
+                </a:gridCol>
               </a:tblGrid>
               <a:tr h="365760">
                 <a:tc>
                   <a:txBody>
-                    <a:bodyPr wrap="square"/>
+                    <a:bodyPr/>
                     <a:lstStyle/>
                     <a:p>
                       <a:pPr algn="ctr"/>
@@ -7339,7 +7644,7 @@
                 </a:tc>
                 <a:tc>
                   <a:txBody>
-                    <a:bodyPr wrap="square"/>
+                    <a:bodyPr/>
                     <a:lstStyle/>
                     <a:p>
                       <a:pPr algn="ctr"/>
@@ -7359,11 +7664,16 @@
                     </a:solidFill>
                   </a:tcPr>
                 </a:tc>
+                <a:extLst>
+                  <a:ext uri="{0D108BD9-81ED-4DB2-BD59-A6C34878D82A}">
+                    <a16:rowId xmlns:a16="http://schemas.microsoft.com/office/drawing/2014/main" val="10000"/>
+                  </a:ext>
+                </a:extLst>
               </a:tr>
               <a:tr h="365760">
                 <a:tc>
                   <a:txBody>
-                    <a:bodyPr wrap="square"/>
+                    <a:bodyPr/>
                     <a:lstStyle/>
                     <a:p>
                       <a:pPr algn="ctr"/>
@@ -7385,7 +7695,7 @@
                 </a:tc>
                 <a:tc>
                   <a:txBody>
-                    <a:bodyPr wrap="square"/>
+                    <a:bodyPr/>
                     <a:lstStyle/>
                     <a:p>
                       <a:pPr algn="ctr"/>
@@ -7405,11 +7715,16 @@
                     </a:solidFill>
                   </a:tcPr>
                 </a:tc>
+                <a:extLst>
+                  <a:ext uri="{0D108BD9-81ED-4DB2-BD59-A6C34878D82A}">
+                    <a16:rowId xmlns:a16="http://schemas.microsoft.com/office/drawing/2014/main" val="10001"/>
+                  </a:ext>
+                </a:extLst>
               </a:tr>
               <a:tr h="365760">
                 <a:tc>
                   <a:txBody>
-                    <a:bodyPr wrap="square"/>
+                    <a:bodyPr/>
                     <a:lstStyle/>
                     <a:p>
                       <a:pPr algn="ctr"/>
@@ -7431,7 +7746,7 @@
                 </a:tc>
                 <a:tc>
                   <a:txBody>
-                    <a:bodyPr wrap="square"/>
+                    <a:bodyPr/>
                     <a:lstStyle/>
                     <a:p>
                       <a:pPr algn="ctr"/>
@@ -7451,11 +7766,16 @@
                     </a:solidFill>
                   </a:tcPr>
                 </a:tc>
+                <a:extLst>
+                  <a:ext uri="{0D108BD9-81ED-4DB2-BD59-A6C34878D82A}">
+                    <a16:rowId xmlns:a16="http://schemas.microsoft.com/office/drawing/2014/main" val="10002"/>
+                  </a:ext>
+                </a:extLst>
               </a:tr>
               <a:tr h="365760">
                 <a:tc>
                   <a:txBody>
-                    <a:bodyPr wrap="square"/>
+                    <a:bodyPr/>
                     <a:lstStyle/>
                     <a:p>
                       <a:pPr algn="ctr"/>
@@ -7477,7 +7797,7 @@
                 </a:tc>
                 <a:tc>
                   <a:txBody>
-                    <a:bodyPr wrap="square"/>
+                    <a:bodyPr/>
                     <a:lstStyle/>
                     <a:p>
                       <a:pPr algn="ctr"/>
@@ -7497,11 +7817,16 @@
                     </a:solidFill>
                   </a:tcPr>
                 </a:tc>
+                <a:extLst>
+                  <a:ext uri="{0D108BD9-81ED-4DB2-BD59-A6C34878D82A}">
+                    <a16:rowId xmlns:a16="http://schemas.microsoft.com/office/drawing/2014/main" val="10003"/>
+                  </a:ext>
+                </a:extLst>
               </a:tr>
               <a:tr h="365760">
                 <a:tc>
                   <a:txBody>
-                    <a:bodyPr wrap="square"/>
+                    <a:bodyPr/>
                     <a:lstStyle/>
                     <a:p>
                       <a:pPr algn="ctr"/>
@@ -7523,7 +7848,7 @@
                 </a:tc>
                 <a:tc>
                   <a:txBody>
-                    <a:bodyPr wrap="square"/>
+                    <a:bodyPr/>
                     <a:lstStyle/>
                     <a:p>
                       <a:pPr algn="ctr"/>
@@ -7543,11 +7868,16 @@
                     </a:solidFill>
                   </a:tcPr>
                 </a:tc>
+                <a:extLst>
+                  <a:ext uri="{0D108BD9-81ED-4DB2-BD59-A6C34878D82A}">
+                    <a16:rowId xmlns:a16="http://schemas.microsoft.com/office/drawing/2014/main" val="10004"/>
+                  </a:ext>
+                </a:extLst>
               </a:tr>
               <a:tr h="365760">
                 <a:tc>
                   <a:txBody>
-                    <a:bodyPr wrap="square"/>
+                    <a:bodyPr/>
                     <a:lstStyle/>
                     <a:p>
                       <a:pPr algn="ctr"/>
@@ -7569,7 +7899,7 @@
                 </a:tc>
                 <a:tc>
                   <a:txBody>
-                    <a:bodyPr wrap="square"/>
+                    <a:bodyPr/>
                     <a:lstStyle/>
                     <a:p>
                       <a:pPr algn="ctr"/>
@@ -7589,6 +7919,11 @@
                     </a:solidFill>
                   </a:tcPr>
                 </a:tc>
+                <a:extLst>
+                  <a:ext uri="{0D108BD9-81ED-4DB2-BD59-A6C34878D82A}">
+                    <a16:rowId xmlns:a16="http://schemas.microsoft.com/office/drawing/2014/main" val="10005"/>
+                  </a:ext>
+                </a:extLst>
               </a:tr>
             </a:tbl>
           </a:graphicData>
@@ -7634,6 +7969,7 @@
           <a:lstStyle/>
           <a:p>
             <a:pPr algn="ctr"/>
+            <a:endParaRPr/>
           </a:p>
         </p:txBody>
       </p:sp>
@@ -7745,6 +8081,7 @@
           <a:lstStyle/>
           <a:p>
             <a:pPr algn="ctr"/>
+            <a:endParaRPr/>
           </a:p>
         </p:txBody>
       </p:sp>
@@ -7788,6 +8125,7 @@
           <a:lstStyle/>
           <a:p>
             <a:pPr algn="ctr"/>
+            <a:endParaRPr/>
           </a:p>
         </p:txBody>
       </p:sp>
@@ -7933,6 +8271,7 @@
           <a:lstStyle/>
           <a:p>
             <a:pPr algn="ctr"/>
+            <a:endParaRPr/>
           </a:p>
         </p:txBody>
       </p:sp>
@@ -7976,6 +8315,7 @@
           <a:lstStyle/>
           <a:p>
             <a:pPr algn="ctr"/>
+            <a:endParaRPr/>
           </a:p>
         </p:txBody>
       </p:sp>
@@ -8121,6 +8461,7 @@
           <a:lstStyle/>
           <a:p>
             <a:pPr algn="ctr"/>
+            <a:endParaRPr/>
           </a:p>
         </p:txBody>
       </p:sp>
@@ -8164,6 +8505,7 @@
           <a:lstStyle/>
           <a:p>
             <a:pPr algn="ctr"/>
+            <a:endParaRPr/>
           </a:p>
         </p:txBody>
       </p:sp>
@@ -8309,6 +8651,7 @@
           <a:lstStyle/>
           <a:p>
             <a:pPr algn="ctr"/>
+            <a:endParaRPr/>
           </a:p>
         </p:txBody>
       </p:sp>
@@ -8352,6 +8695,7 @@
           <a:lstStyle/>
           <a:p>
             <a:pPr algn="ctr"/>
+            <a:endParaRPr/>
           </a:p>
         </p:txBody>
       </p:sp>
@@ -8466,7 +8810,7 @@
 </file>
 
 <file path=ppt/slides/slide4.xml><?xml version="1.0" encoding="utf-8"?>
-<p:sld xmlns:a="http://schemas.openxmlformats.org/drawingml/2006/main" xmlns:p="http://schemas.openxmlformats.org/presentationml/2006/main" xmlns:r="http://schemas.openxmlformats.org/officeDocument/2006/relationships">
+<p:sld xmlns:a="http://schemas.openxmlformats.org/drawingml/2006/main" xmlns:r="http://schemas.openxmlformats.org/officeDocument/2006/relationships" xmlns:p="http://schemas.openxmlformats.org/presentationml/2006/main">
   <p:cSld>
     <p:bg>
       <p:bgPr>
@@ -8482,7 +8826,14 @@
         <p:cNvGrpSpPr/>
         <p:nvPr/>
       </p:nvGrpSpPr>
-      <p:grpSpPr/>
+      <p:grpSpPr>
+        <a:xfrm>
+          <a:off x="0" y="0"/>
+          <a:ext cx="0" cy="0"/>
+          <a:chOff x="0" y="0"/>
+          <a:chExt cx="0" cy="0"/>
+        </a:xfrm>
+      </p:grpSpPr>
       <p:sp>
         <p:nvSpPr>
           <p:cNvPr id="2" name="Rectangle 1"/>
@@ -8523,6 +8874,7 @@
           <a:lstStyle/>
           <a:p>
             <a:pPr algn="ctr"/>
+            <a:endParaRPr/>
           </a:p>
         </p:txBody>
       </p:sp>
@@ -8634,6 +8986,7 @@
           <a:lstStyle/>
           <a:p>
             <a:pPr algn="ctr"/>
+            <a:endParaRPr/>
           </a:p>
         </p:txBody>
       </p:sp>
@@ -8711,6 +9064,7 @@
           <a:lstStyle/>
           <a:p>
             <a:pPr algn="ctr"/>
+            <a:endParaRPr/>
           </a:p>
         </p:txBody>
       </p:sp>
@@ -8822,6 +9176,7 @@
           <a:lstStyle/>
           <a:p>
             <a:pPr algn="ctr"/>
+            <a:endParaRPr/>
           </a:p>
         </p:txBody>
       </p:sp>
@@ -8899,6 +9254,7 @@
           <a:lstStyle/>
           <a:p>
             <a:pPr algn="ctr"/>
+            <a:endParaRPr/>
           </a:p>
         </p:txBody>
       </p:sp>
@@ -9010,6 +9366,7 @@
           <a:lstStyle/>
           <a:p>
             <a:pPr algn="ctr"/>
+            <a:endParaRPr/>
           </a:p>
         </p:txBody>
       </p:sp>
@@ -9087,6 +9444,7 @@
           <a:lstStyle/>
           <a:p>
             <a:pPr algn="ctr"/>
+            <a:endParaRPr/>
           </a:p>
         </p:txBody>
       </p:sp>
@@ -9198,6 +9556,7 @@
           <a:lstStyle/>
           <a:p>
             <a:pPr algn="ctr"/>
+            <a:endParaRPr/>
           </a:p>
         </p:txBody>
       </p:sp>
@@ -9275,6 +9634,7 @@
           <a:lstStyle/>
           <a:p>
             <a:pPr algn="ctr"/>
+            <a:endParaRPr/>
           </a:p>
         </p:txBody>
       </p:sp>
@@ -9386,6 +9746,7 @@
           <a:lstStyle/>
           <a:p>
             <a:pPr algn="ctr"/>
+            <a:endParaRPr/>
           </a:p>
         </p:txBody>
       </p:sp>
@@ -9463,6 +9824,7 @@
           <a:lstStyle/>
           <a:p>
             <a:pPr algn="ctr"/>
+            <a:endParaRPr/>
           </a:p>
         </p:txBody>
       </p:sp>
@@ -9574,6 +9936,7 @@
           <a:lstStyle/>
           <a:p>
             <a:pPr algn="ctr"/>
+            <a:endParaRPr/>
           </a:p>
         </p:txBody>
       </p:sp>
@@ -9651,6 +10014,7 @@
           <a:lstStyle/>
           <a:p>
             <a:pPr algn="ctr"/>
+            <a:endParaRPr/>
           </a:p>
         </p:txBody>
       </p:sp>
@@ -9762,6 +10126,7 @@
           <a:lstStyle/>
           <a:p>
             <a:pPr algn="ctr"/>
+            <a:endParaRPr/>
           </a:p>
         </p:txBody>
       </p:sp>
@@ -9839,6 +10204,7 @@
           <a:lstStyle/>
           <a:p>
             <a:pPr algn="ctr"/>
+            <a:endParaRPr/>
           </a:p>
         </p:txBody>
       </p:sp>
@@ -9916,6 +10282,7 @@
           <a:lstStyle/>
           <a:p>
             <a:pPr algn="ctr"/>
+            <a:endParaRPr/>
           </a:p>
         </p:txBody>
       </p:sp>
@@ -9962,7 +10329,7 @@
 </file>
 
 <file path=ppt/slides/slide5.xml><?xml version="1.0" encoding="utf-8"?>
-<p:sld xmlns:a="http://schemas.openxmlformats.org/drawingml/2006/main" xmlns:p="http://schemas.openxmlformats.org/presentationml/2006/main" xmlns:r="http://schemas.openxmlformats.org/officeDocument/2006/relationships">
+<p:sld xmlns:a="http://schemas.openxmlformats.org/drawingml/2006/main" xmlns:r="http://schemas.openxmlformats.org/officeDocument/2006/relationships" xmlns:p="http://schemas.openxmlformats.org/presentationml/2006/main">
   <p:cSld>
     <p:bg>
       <p:bgPr>
@@ -9978,7 +10345,14 @@
         <p:cNvGrpSpPr/>
         <p:nvPr/>
       </p:nvGrpSpPr>
-      <p:grpSpPr/>
+      <p:grpSpPr>
+        <a:xfrm>
+          <a:off x="0" y="0"/>
+          <a:ext cx="0" cy="0"/>
+          <a:chOff x="0" y="0"/>
+          <a:chExt cx="0" cy="0"/>
+        </a:xfrm>
+      </p:grpSpPr>
       <p:sp>
         <p:nvSpPr>
           <p:cNvPr id="2" name="Rectangle 1"/>
@@ -10019,6 +10393,7 @@
           <a:lstStyle/>
           <a:p>
             <a:pPr algn="ctr"/>
+            <a:endParaRPr/>
           </a:p>
         </p:txBody>
       </p:sp>
@@ -10130,6 +10505,7 @@
           <a:lstStyle/>
           <a:p>
             <a:pPr algn="ctr"/>
+            <a:endParaRPr/>
           </a:p>
         </p:txBody>
       </p:sp>
@@ -10173,6 +10549,7 @@
           <a:lstStyle/>
           <a:p>
             <a:pPr algn="ctr"/>
+            <a:endParaRPr/>
           </a:p>
         </p:txBody>
       </p:sp>
@@ -10319,6 +10696,7 @@
           <a:lstStyle/>
           <a:p>
             <a:pPr algn="ctr"/>
+            <a:endParaRPr/>
           </a:p>
         </p:txBody>
       </p:sp>
@@ -10362,6 +10740,7 @@
           <a:lstStyle/>
           <a:p>
             <a:pPr algn="ctr"/>
+            <a:endParaRPr/>
           </a:p>
         </p:txBody>
       </p:sp>
@@ -10508,6 +10887,7 @@
           <a:lstStyle/>
           <a:p>
             <a:pPr algn="ctr"/>
+            <a:endParaRPr/>
           </a:p>
         </p:txBody>
       </p:sp>
@@ -10551,6 +10931,7 @@
           <a:lstStyle/>
           <a:p>
             <a:pPr algn="ctr"/>
+            <a:endParaRPr/>
           </a:p>
         </p:txBody>
       </p:sp>
@@ -10697,6 +11078,7 @@
           <a:lstStyle/>
           <a:p>
             <a:pPr algn="ctr"/>
+            <a:endParaRPr/>
           </a:p>
         </p:txBody>
       </p:sp>
@@ -10740,6 +11122,7 @@
           <a:lstStyle/>
           <a:p>
             <a:pPr algn="ctr"/>
+            <a:endParaRPr/>
           </a:p>
         </p:txBody>
       </p:sp>
@@ -10855,7 +11238,7 @@
 </file>
 
 <file path=ppt/slides/slide6.xml><?xml version="1.0" encoding="utf-8"?>
-<p:sld xmlns:a="http://schemas.openxmlformats.org/drawingml/2006/main" xmlns:p="http://schemas.openxmlformats.org/presentationml/2006/main" xmlns:r="http://schemas.openxmlformats.org/officeDocument/2006/relationships">
+<p:sld xmlns:a="http://schemas.openxmlformats.org/drawingml/2006/main" xmlns:r="http://schemas.openxmlformats.org/officeDocument/2006/relationships" xmlns:p="http://schemas.openxmlformats.org/presentationml/2006/main">
   <p:cSld>
     <p:bg>
       <p:bgPr>
@@ -10871,7 +11254,14 @@
         <p:cNvGrpSpPr/>
         <p:nvPr/>
       </p:nvGrpSpPr>
-      <p:grpSpPr/>
+      <p:grpSpPr>
+        <a:xfrm>
+          <a:off x="0" y="0"/>
+          <a:ext cx="0" cy="0"/>
+          <a:chOff x="0" y="0"/>
+          <a:chExt cx="0" cy="0"/>
+        </a:xfrm>
+      </p:grpSpPr>
       <p:sp>
         <p:nvSpPr>
           <p:cNvPr id="2" name="Rectangle 1"/>
@@ -10912,6 +11302,7 @@
           <a:lstStyle/>
           <a:p>
             <a:pPr algn="ctr"/>
+            <a:endParaRPr/>
           </a:p>
         </p:txBody>
       </p:sp>
@@ -11036,13 +11427,25 @@
                 <a:tableStyleId>{5C22544A-7EE6-4342-B048-85BDC9FD1C3A}</a:tableStyleId>
               </a:tblPr>
               <a:tblGrid>
-                <a:gridCol w="2834640"/>
-                <a:gridCol w="2834640"/>
+                <a:gridCol w="2834640">
+                  <a:extLst>
+                    <a:ext uri="{9D8B030D-6E8A-4147-A177-3AD203B41FA5}">
+                      <a16:colId xmlns:a16="http://schemas.microsoft.com/office/drawing/2014/main" val="20000"/>
+                    </a:ext>
+                  </a:extLst>
+                </a:gridCol>
+                <a:gridCol w="2834640">
+                  <a:extLst>
+                    <a:ext uri="{9D8B030D-6E8A-4147-A177-3AD203B41FA5}">
+                      <a16:colId xmlns:a16="http://schemas.microsoft.com/office/drawing/2014/main" val="20001"/>
+                    </a:ext>
+                  </a:extLst>
+                </a:gridCol>
               </a:tblGrid>
               <a:tr h="350520">
                 <a:tc>
                   <a:txBody>
-                    <a:bodyPr wrap="square"/>
+                    <a:bodyPr/>
                     <a:lstStyle/>
                     <a:p>
                       <a:pPr algn="ctr"/>
@@ -11064,7 +11467,7 @@
                 </a:tc>
                 <a:tc>
                   <a:txBody>
-                    <a:bodyPr wrap="square"/>
+                    <a:bodyPr/>
                     <a:lstStyle/>
                     <a:p>
                       <a:pPr algn="ctr"/>
@@ -11084,11 +11487,16 @@
                     </a:solidFill>
                   </a:tcPr>
                 </a:tc>
+                <a:extLst>
+                  <a:ext uri="{0D108BD9-81ED-4DB2-BD59-A6C34878D82A}">
+                    <a16:rowId xmlns:a16="http://schemas.microsoft.com/office/drawing/2014/main" val="10000"/>
+                  </a:ext>
+                </a:extLst>
               </a:tr>
               <a:tr h="350520">
                 <a:tc>
                   <a:txBody>
-                    <a:bodyPr wrap="square"/>
+                    <a:bodyPr/>
                     <a:lstStyle/>
                     <a:p>
                       <a:pPr algn="ctr"/>
@@ -11110,7 +11518,7 @@
                 </a:tc>
                 <a:tc>
                   <a:txBody>
-                    <a:bodyPr wrap="square"/>
+                    <a:bodyPr/>
                     <a:lstStyle/>
                     <a:p>
                       <a:pPr algn="ctr"/>
@@ -11130,11 +11538,16 @@
                     </a:solidFill>
                   </a:tcPr>
                 </a:tc>
+                <a:extLst>
+                  <a:ext uri="{0D108BD9-81ED-4DB2-BD59-A6C34878D82A}">
+                    <a16:rowId xmlns:a16="http://schemas.microsoft.com/office/drawing/2014/main" val="10001"/>
+                  </a:ext>
+                </a:extLst>
               </a:tr>
               <a:tr h="350520">
                 <a:tc>
                   <a:txBody>
-                    <a:bodyPr wrap="square"/>
+                    <a:bodyPr/>
                     <a:lstStyle/>
                     <a:p>
                       <a:pPr algn="ctr"/>
@@ -11156,7 +11569,7 @@
                 </a:tc>
                 <a:tc>
                   <a:txBody>
-                    <a:bodyPr wrap="square"/>
+                    <a:bodyPr/>
                     <a:lstStyle/>
                     <a:p>
                       <a:pPr algn="ctr"/>
@@ -11176,11 +11589,16 @@
                     </a:solidFill>
                   </a:tcPr>
                 </a:tc>
+                <a:extLst>
+                  <a:ext uri="{0D108BD9-81ED-4DB2-BD59-A6C34878D82A}">
+                    <a16:rowId xmlns:a16="http://schemas.microsoft.com/office/drawing/2014/main" val="10002"/>
+                  </a:ext>
+                </a:extLst>
               </a:tr>
               <a:tr h="350520">
                 <a:tc>
                   <a:txBody>
-                    <a:bodyPr wrap="square"/>
+                    <a:bodyPr/>
                     <a:lstStyle/>
                     <a:p>
                       <a:pPr algn="ctr"/>
@@ -11202,7 +11620,7 @@
                 </a:tc>
                 <a:tc>
                   <a:txBody>
-                    <a:bodyPr wrap="square"/>
+                    <a:bodyPr/>
                     <a:lstStyle/>
                     <a:p>
                       <a:pPr algn="ctr"/>
@@ -11222,11 +11640,16 @@
                     </a:solidFill>
                   </a:tcPr>
                 </a:tc>
+                <a:extLst>
+                  <a:ext uri="{0D108BD9-81ED-4DB2-BD59-A6C34878D82A}">
+                    <a16:rowId xmlns:a16="http://schemas.microsoft.com/office/drawing/2014/main" val="10003"/>
+                  </a:ext>
+                </a:extLst>
               </a:tr>
               <a:tr h="350520">
                 <a:tc>
                   <a:txBody>
-                    <a:bodyPr wrap="square"/>
+                    <a:bodyPr/>
                     <a:lstStyle/>
                     <a:p>
                       <a:pPr algn="ctr"/>
@@ -11248,7 +11671,7 @@
                 </a:tc>
                 <a:tc>
                   <a:txBody>
-                    <a:bodyPr wrap="square"/>
+                    <a:bodyPr/>
                     <a:lstStyle/>
                     <a:p>
                       <a:pPr algn="ctr"/>
@@ -11268,11 +11691,16 @@
                     </a:solidFill>
                   </a:tcPr>
                 </a:tc>
+                <a:extLst>
+                  <a:ext uri="{0D108BD9-81ED-4DB2-BD59-A6C34878D82A}">
+                    <a16:rowId xmlns:a16="http://schemas.microsoft.com/office/drawing/2014/main" val="10004"/>
+                  </a:ext>
+                </a:extLst>
               </a:tr>
               <a:tr h="350520">
                 <a:tc>
                   <a:txBody>
-                    <a:bodyPr wrap="square"/>
+                    <a:bodyPr/>
                     <a:lstStyle/>
                     <a:p>
                       <a:pPr algn="ctr"/>
@@ -11294,7 +11722,7 @@
                 </a:tc>
                 <a:tc>
                   <a:txBody>
-                    <a:bodyPr wrap="square"/>
+                    <a:bodyPr/>
                     <a:lstStyle/>
                     <a:p>
                       <a:pPr algn="ctr"/>
@@ -11314,6 +11742,11 @@
                     </a:solidFill>
                   </a:tcPr>
                 </a:tc>
+                <a:extLst>
+                  <a:ext uri="{0D108BD9-81ED-4DB2-BD59-A6C34878D82A}">
+                    <a16:rowId xmlns:a16="http://schemas.microsoft.com/office/drawing/2014/main" val="10005"/>
+                  </a:ext>
+                </a:extLst>
               </a:tr>
             </a:tbl>
           </a:graphicData>
@@ -11393,6 +11826,7 @@
           <a:lstStyle/>
           <a:p>
             <a:pPr algn="ctr"/>
+            <a:endParaRPr/>
           </a:p>
         </p:txBody>
       </p:sp>
@@ -11436,6 +11870,7 @@
           <a:lstStyle/>
           <a:p>
             <a:pPr algn="ctr"/>
+            <a:endParaRPr/>
           </a:p>
         </p:txBody>
       </p:sp>
@@ -11550,6 +11985,7 @@
           <a:lstStyle/>
           <a:p>
             <a:pPr algn="ctr"/>
+            <a:endParaRPr/>
           </a:p>
         </p:txBody>
       </p:sp>
@@ -11593,6 +12029,7 @@
           <a:lstStyle/>
           <a:p>
             <a:pPr algn="ctr"/>
+            <a:endParaRPr/>
           </a:p>
         </p:txBody>
       </p:sp>
@@ -11706,6 +12143,7 @@
           <a:lstStyle/>
           <a:p>
             <a:pPr algn="ctr"/>
+            <a:endParaRPr/>
           </a:p>
         </p:txBody>
       </p:sp>
@@ -11749,6 +12187,7 @@
           <a:lstStyle/>
           <a:p>
             <a:pPr algn="ctr"/>
+            <a:endParaRPr/>
           </a:p>
         </p:txBody>
       </p:sp>
@@ -11862,6 +12301,7 @@
           <a:lstStyle/>
           <a:p>
             <a:pPr algn="ctr"/>
+            <a:endParaRPr/>
           </a:p>
         </p:txBody>
       </p:sp>
@@ -11942,7 +12382,7 @@
 </file>
 
 <file path=ppt/slides/slide7.xml><?xml version="1.0" encoding="utf-8"?>
-<p:sld xmlns:a="http://schemas.openxmlformats.org/drawingml/2006/main" xmlns:p="http://schemas.openxmlformats.org/presentationml/2006/main" xmlns:r="http://schemas.openxmlformats.org/officeDocument/2006/relationships">
+<p:sld xmlns:a="http://schemas.openxmlformats.org/drawingml/2006/main" xmlns:r="http://schemas.openxmlformats.org/officeDocument/2006/relationships" xmlns:p="http://schemas.openxmlformats.org/presentationml/2006/main">
   <p:cSld>
     <p:bg>
       <p:bgPr>
@@ -11958,7 +12398,14 @@
         <p:cNvGrpSpPr/>
         <p:nvPr/>
       </p:nvGrpSpPr>
-      <p:grpSpPr/>
+      <p:grpSpPr>
+        <a:xfrm>
+          <a:off x="0" y="0"/>
+          <a:ext cx="0" cy="0"/>
+          <a:chOff x="0" y="0"/>
+          <a:chExt cx="0" cy="0"/>
+        </a:xfrm>
+      </p:grpSpPr>
       <p:sp>
         <p:nvSpPr>
           <p:cNvPr id="2" name="Rectangle 1"/>
@@ -11999,6 +12446,7 @@
           <a:lstStyle/>
           <a:p>
             <a:pPr algn="ctr"/>
+            <a:endParaRPr/>
           </a:p>
         </p:txBody>
       </p:sp>
@@ -12110,6 +12558,7 @@
           <a:lstStyle/>
           <a:p>
             <a:pPr algn="ctr"/>
+            <a:endParaRPr/>
           </a:p>
         </p:txBody>
       </p:sp>
@@ -12153,6 +12602,7 @@
           <a:lstStyle/>
           <a:p>
             <a:pPr algn="ctr"/>
+            <a:endParaRPr/>
           </a:p>
         </p:txBody>
       </p:sp>
@@ -12266,6 +12716,7 @@
           <a:lstStyle/>
           <a:p>
             <a:pPr algn="ctr"/>
+            <a:endParaRPr/>
           </a:p>
         </p:txBody>
       </p:sp>
@@ -12309,6 +12760,7 @@
           <a:lstStyle/>
           <a:p>
             <a:pPr algn="ctr"/>
+            <a:endParaRPr/>
           </a:p>
         </p:txBody>
       </p:sp>
@@ -12422,6 +12874,7 @@
           <a:lstStyle/>
           <a:p>
             <a:pPr algn="ctr"/>
+            <a:endParaRPr/>
           </a:p>
         </p:txBody>
       </p:sp>
@@ -12465,6 +12918,7 @@
           <a:lstStyle/>
           <a:p>
             <a:pPr algn="ctr"/>
+            <a:endParaRPr/>
           </a:p>
         </p:txBody>
       </p:sp>
@@ -12578,6 +13032,7 @@
           <a:lstStyle/>
           <a:p>
             <a:pPr algn="ctr"/>
+            <a:endParaRPr/>
           </a:p>
         </p:txBody>
       </p:sp>
@@ -12621,6 +13076,7 @@
           <a:lstStyle/>
           <a:p>
             <a:pPr algn="ctr"/>
+            <a:endParaRPr/>
           </a:p>
         </p:txBody>
       </p:sp>
@@ -12735,6 +13191,7 @@
           <a:lstStyle/>
           <a:p>
             <a:pPr algn="ctr"/>
+            <a:endParaRPr/>
           </a:p>
         </p:txBody>
       </p:sp>
@@ -12778,6 +13235,7 @@
           <a:lstStyle/>
           <a:p>
             <a:pPr algn="ctr"/>
+            <a:endParaRPr/>
           </a:p>
         </p:txBody>
       </p:sp>
@@ -12891,6 +13349,7 @@
           <a:lstStyle/>
           <a:p>
             <a:pPr algn="ctr"/>
+            <a:endParaRPr/>
           </a:p>
         </p:txBody>
       </p:sp>
@@ -12934,6 +13393,7 @@
           <a:lstStyle/>
           <a:p>
             <a:pPr algn="ctr"/>
+            <a:endParaRPr/>
           </a:p>
         </p:txBody>
       </p:sp>
@@ -13048,6 +13508,7 @@
           <a:lstStyle/>
           <a:p>
             <a:pPr algn="ctr"/>
+            <a:endParaRPr/>
           </a:p>
         </p:txBody>
       </p:sp>
@@ -13091,6 +13552,7 @@
           <a:lstStyle/>
           <a:p>
             <a:pPr algn="ctr"/>
+            <a:endParaRPr/>
           </a:p>
         </p:txBody>
       </p:sp>
@@ -13204,6 +13666,7 @@
           <a:lstStyle/>
           <a:p>
             <a:pPr algn="ctr"/>
+            <a:endParaRPr/>
           </a:p>
         </p:txBody>
       </p:sp>
@@ -13247,6 +13710,7 @@
           <a:lstStyle/>
           <a:p>
             <a:pPr algn="ctr"/>
+            <a:endParaRPr/>
           </a:p>
         </p:txBody>
       </p:sp>
@@ -13330,7 +13794,7 @@
 </file>
 
 <file path=ppt/slides/slide8.xml><?xml version="1.0" encoding="utf-8"?>
-<p:sld xmlns:a="http://schemas.openxmlformats.org/drawingml/2006/main" xmlns:p="http://schemas.openxmlformats.org/presentationml/2006/main" xmlns:r="http://schemas.openxmlformats.org/officeDocument/2006/relationships">
+<p:sld xmlns:a="http://schemas.openxmlformats.org/drawingml/2006/main" xmlns:r="http://schemas.openxmlformats.org/officeDocument/2006/relationships" xmlns:p="http://schemas.openxmlformats.org/presentationml/2006/main">
   <p:cSld>
     <p:bg>
       <p:bgPr>
@@ -13346,7 +13810,14 @@
         <p:cNvGrpSpPr/>
         <p:nvPr/>
       </p:nvGrpSpPr>
-      <p:grpSpPr/>
+      <p:grpSpPr>
+        <a:xfrm>
+          <a:off x="0" y="0"/>
+          <a:ext cx="0" cy="0"/>
+          <a:chOff x="0" y="0"/>
+          <a:chExt cx="0" cy="0"/>
+        </a:xfrm>
+      </p:grpSpPr>
       <p:sp>
         <p:nvSpPr>
           <p:cNvPr id="2" name="Rectangle 1"/>
@@ -13387,6 +13858,7 @@
           <a:lstStyle/>
           <a:p>
             <a:pPr algn="ctr"/>
+            <a:endParaRPr/>
           </a:p>
         </p:txBody>
       </p:sp>
@@ -13511,17 +13983,53 @@
                 <a:tableStyleId>{5C22544A-7EE6-4342-B048-85BDC9FD1C3A}</a:tableStyleId>
               </a:tblPr>
               <a:tblGrid>
-                <a:gridCol w="1905000"/>
-                <a:gridCol w="1905000"/>
-                <a:gridCol w="1905000"/>
-                <a:gridCol w="1905000"/>
-                <a:gridCol w="1905000"/>
-                <a:gridCol w="1905000"/>
+                <a:gridCol w="1905000">
+                  <a:extLst>
+                    <a:ext uri="{9D8B030D-6E8A-4147-A177-3AD203B41FA5}">
+                      <a16:colId xmlns:a16="http://schemas.microsoft.com/office/drawing/2014/main" val="20000"/>
+                    </a:ext>
+                  </a:extLst>
+                </a:gridCol>
+                <a:gridCol w="1905000">
+                  <a:extLst>
+                    <a:ext uri="{9D8B030D-6E8A-4147-A177-3AD203B41FA5}">
+                      <a16:colId xmlns:a16="http://schemas.microsoft.com/office/drawing/2014/main" val="20001"/>
+                    </a:ext>
+                  </a:extLst>
+                </a:gridCol>
+                <a:gridCol w="1905000">
+                  <a:extLst>
+                    <a:ext uri="{9D8B030D-6E8A-4147-A177-3AD203B41FA5}">
+                      <a16:colId xmlns:a16="http://schemas.microsoft.com/office/drawing/2014/main" val="20002"/>
+                    </a:ext>
+                  </a:extLst>
+                </a:gridCol>
+                <a:gridCol w="1905000">
+                  <a:extLst>
+                    <a:ext uri="{9D8B030D-6E8A-4147-A177-3AD203B41FA5}">
+                      <a16:colId xmlns:a16="http://schemas.microsoft.com/office/drawing/2014/main" val="20003"/>
+                    </a:ext>
+                  </a:extLst>
+                </a:gridCol>
+                <a:gridCol w="1905000">
+                  <a:extLst>
+                    <a:ext uri="{9D8B030D-6E8A-4147-A177-3AD203B41FA5}">
+                      <a16:colId xmlns:a16="http://schemas.microsoft.com/office/drawing/2014/main" val="20004"/>
+                    </a:ext>
+                  </a:extLst>
+                </a:gridCol>
+                <a:gridCol w="1905000">
+                  <a:extLst>
+                    <a:ext uri="{9D8B030D-6E8A-4147-A177-3AD203B41FA5}">
+                      <a16:colId xmlns:a16="http://schemas.microsoft.com/office/drawing/2014/main" val="20005"/>
+                    </a:ext>
+                  </a:extLst>
+                </a:gridCol>
               </a:tblGrid>
               <a:tr h="301752">
                 <a:tc>
                   <a:txBody>
-                    <a:bodyPr wrap="square"/>
+                    <a:bodyPr/>
                     <a:lstStyle/>
                     <a:p>
                       <a:pPr algn="ctr"/>
@@ -13543,7 +14051,7 @@
                 </a:tc>
                 <a:tc>
                   <a:txBody>
-                    <a:bodyPr wrap="square"/>
+                    <a:bodyPr/>
                     <a:lstStyle/>
                     <a:p>
                       <a:pPr algn="ctr"/>
@@ -13565,7 +14073,7 @@
                 </a:tc>
                 <a:tc>
                   <a:txBody>
-                    <a:bodyPr wrap="square"/>
+                    <a:bodyPr/>
                     <a:lstStyle/>
                     <a:p>
                       <a:pPr algn="ctr"/>
@@ -13587,7 +14095,7 @@
                 </a:tc>
                 <a:tc>
                   <a:txBody>
-                    <a:bodyPr wrap="square"/>
+                    <a:bodyPr/>
                     <a:lstStyle/>
                     <a:p>
                       <a:pPr algn="ctr"/>
@@ -13609,7 +14117,7 @@
                 </a:tc>
                 <a:tc>
                   <a:txBody>
-                    <a:bodyPr wrap="square"/>
+                    <a:bodyPr/>
                     <a:lstStyle/>
                     <a:p>
                       <a:pPr algn="ctr"/>
@@ -13631,7 +14139,7 @@
                 </a:tc>
                 <a:tc>
                   <a:txBody>
-                    <a:bodyPr wrap="square"/>
+                    <a:bodyPr/>
                     <a:lstStyle/>
                     <a:p>
                       <a:pPr algn="ctr"/>
@@ -13651,11 +14159,16 @@
                     </a:solidFill>
                   </a:tcPr>
                 </a:tc>
+                <a:extLst>
+                  <a:ext uri="{0D108BD9-81ED-4DB2-BD59-A6C34878D82A}">
+                    <a16:rowId xmlns:a16="http://schemas.microsoft.com/office/drawing/2014/main" val="10000"/>
+                  </a:ext>
+                </a:extLst>
               </a:tr>
               <a:tr h="301752">
                 <a:tc>
                   <a:txBody>
-                    <a:bodyPr wrap="square"/>
+                    <a:bodyPr/>
                     <a:lstStyle/>
                     <a:p>
                       <a:pPr algn="ctr"/>
@@ -13677,7 +14190,7 @@
                 </a:tc>
                 <a:tc>
                   <a:txBody>
-                    <a:bodyPr wrap="square"/>
+                    <a:bodyPr/>
                     <a:lstStyle/>
                     <a:p>
                       <a:pPr algn="ctr"/>
@@ -13699,7 +14212,7 @@
                 </a:tc>
                 <a:tc>
                   <a:txBody>
-                    <a:bodyPr wrap="square"/>
+                    <a:bodyPr/>
                     <a:lstStyle/>
                     <a:p>
                       <a:pPr algn="ctr"/>
@@ -13721,7 +14234,7 @@
                 </a:tc>
                 <a:tc>
                   <a:txBody>
-                    <a:bodyPr wrap="square"/>
+                    <a:bodyPr/>
                     <a:lstStyle/>
                     <a:p>
                       <a:pPr algn="ctr"/>
@@ -13743,7 +14256,7 @@
                 </a:tc>
                 <a:tc>
                   <a:txBody>
-                    <a:bodyPr wrap="square"/>
+                    <a:bodyPr/>
                     <a:lstStyle/>
                     <a:p>
                       <a:pPr algn="ctr"/>
@@ -13765,7 +14278,7 @@
                 </a:tc>
                 <a:tc>
                   <a:txBody>
-                    <a:bodyPr wrap="square"/>
+                    <a:bodyPr/>
                     <a:lstStyle/>
                     <a:p>
                       <a:pPr algn="ctr"/>
@@ -13785,11 +14298,16 @@
                     </a:solidFill>
                   </a:tcPr>
                 </a:tc>
+                <a:extLst>
+                  <a:ext uri="{0D108BD9-81ED-4DB2-BD59-A6C34878D82A}">
+                    <a16:rowId xmlns:a16="http://schemas.microsoft.com/office/drawing/2014/main" val="10001"/>
+                  </a:ext>
+                </a:extLst>
               </a:tr>
               <a:tr h="301752">
                 <a:tc>
                   <a:txBody>
-                    <a:bodyPr wrap="square"/>
+                    <a:bodyPr/>
                     <a:lstStyle/>
                     <a:p>
                       <a:pPr algn="ctr"/>
@@ -13811,7 +14329,7 @@
                 </a:tc>
                 <a:tc>
                   <a:txBody>
-                    <a:bodyPr wrap="square"/>
+                    <a:bodyPr/>
                     <a:lstStyle/>
                     <a:p>
                       <a:pPr algn="ctr"/>
@@ -13833,7 +14351,7 @@
                 </a:tc>
                 <a:tc>
                   <a:txBody>
-                    <a:bodyPr wrap="square"/>
+                    <a:bodyPr/>
                     <a:lstStyle/>
                     <a:p>
                       <a:pPr algn="ctr"/>
@@ -13855,7 +14373,7 @@
                 </a:tc>
                 <a:tc>
                   <a:txBody>
-                    <a:bodyPr wrap="square"/>
+                    <a:bodyPr/>
                     <a:lstStyle/>
                     <a:p>
                       <a:pPr algn="ctr"/>
@@ -13877,7 +14395,7 @@
                 </a:tc>
                 <a:tc>
                   <a:txBody>
-                    <a:bodyPr wrap="square"/>
+                    <a:bodyPr/>
                     <a:lstStyle/>
                     <a:p>
                       <a:pPr algn="ctr"/>
@@ -13899,7 +14417,7 @@
                 </a:tc>
                 <a:tc>
                   <a:txBody>
-                    <a:bodyPr wrap="square"/>
+                    <a:bodyPr/>
                     <a:lstStyle/>
                     <a:p>
                       <a:pPr algn="ctr"/>
@@ -13919,11 +14437,16 @@
                     </a:solidFill>
                   </a:tcPr>
                 </a:tc>
+                <a:extLst>
+                  <a:ext uri="{0D108BD9-81ED-4DB2-BD59-A6C34878D82A}">
+                    <a16:rowId xmlns:a16="http://schemas.microsoft.com/office/drawing/2014/main" val="10002"/>
+                  </a:ext>
+                </a:extLst>
               </a:tr>
               <a:tr h="301752">
                 <a:tc>
                   <a:txBody>
-                    <a:bodyPr wrap="square"/>
+                    <a:bodyPr/>
                     <a:lstStyle/>
                     <a:p>
                       <a:pPr algn="ctr"/>
@@ -13945,7 +14468,7 @@
                 </a:tc>
                 <a:tc>
                   <a:txBody>
-                    <a:bodyPr wrap="square"/>
+                    <a:bodyPr/>
                     <a:lstStyle/>
                     <a:p>
                       <a:pPr algn="ctr"/>
@@ -13967,7 +14490,7 @@
                 </a:tc>
                 <a:tc>
                   <a:txBody>
-                    <a:bodyPr wrap="square"/>
+                    <a:bodyPr/>
                     <a:lstStyle/>
                     <a:p>
                       <a:pPr algn="ctr"/>
@@ -13989,7 +14512,7 @@
                 </a:tc>
                 <a:tc>
                   <a:txBody>
-                    <a:bodyPr wrap="square"/>
+                    <a:bodyPr/>
                     <a:lstStyle/>
                     <a:p>
                       <a:pPr algn="ctr"/>
@@ -14011,7 +14534,7 @@
                 </a:tc>
                 <a:tc>
                   <a:txBody>
-                    <a:bodyPr wrap="square"/>
+                    <a:bodyPr/>
                     <a:lstStyle/>
                     <a:p>
                       <a:pPr algn="ctr"/>
@@ -14033,7 +14556,7 @@
                 </a:tc>
                 <a:tc>
                   <a:txBody>
-                    <a:bodyPr wrap="square"/>
+                    <a:bodyPr/>
                     <a:lstStyle/>
                     <a:p>
                       <a:pPr algn="ctr"/>
@@ -14053,11 +14576,16 @@
                     </a:solidFill>
                   </a:tcPr>
                 </a:tc>
+                <a:extLst>
+                  <a:ext uri="{0D108BD9-81ED-4DB2-BD59-A6C34878D82A}">
+                    <a16:rowId xmlns:a16="http://schemas.microsoft.com/office/drawing/2014/main" val="10003"/>
+                  </a:ext>
+                </a:extLst>
               </a:tr>
               <a:tr h="301752">
                 <a:tc>
                   <a:txBody>
-                    <a:bodyPr wrap="square"/>
+                    <a:bodyPr/>
                     <a:lstStyle/>
                     <a:p>
                       <a:pPr algn="ctr"/>
@@ -14079,7 +14607,7 @@
                 </a:tc>
                 <a:tc>
                   <a:txBody>
-                    <a:bodyPr wrap="square"/>
+                    <a:bodyPr/>
                     <a:lstStyle/>
                     <a:p>
                       <a:pPr algn="ctr"/>
@@ -14101,7 +14629,7 @@
                 </a:tc>
                 <a:tc>
                   <a:txBody>
-                    <a:bodyPr wrap="square"/>
+                    <a:bodyPr/>
                     <a:lstStyle/>
                     <a:p>
                       <a:pPr algn="ctr"/>
@@ -14123,7 +14651,7 @@
                 </a:tc>
                 <a:tc>
                   <a:txBody>
-                    <a:bodyPr wrap="square"/>
+                    <a:bodyPr/>
                     <a:lstStyle/>
                     <a:p>
                       <a:pPr algn="ctr"/>
@@ -14145,7 +14673,7 @@
                 </a:tc>
                 <a:tc>
                   <a:txBody>
-                    <a:bodyPr wrap="square"/>
+                    <a:bodyPr/>
                     <a:lstStyle/>
                     <a:p>
                       <a:pPr algn="ctr"/>
@@ -14167,7 +14695,7 @@
                 </a:tc>
                 <a:tc>
                   <a:txBody>
-                    <a:bodyPr wrap="square"/>
+                    <a:bodyPr/>
                     <a:lstStyle/>
                     <a:p>
                       <a:pPr algn="ctr"/>
@@ -14187,11 +14715,16 @@
                     </a:solidFill>
                   </a:tcPr>
                 </a:tc>
+                <a:extLst>
+                  <a:ext uri="{0D108BD9-81ED-4DB2-BD59-A6C34878D82A}">
+                    <a16:rowId xmlns:a16="http://schemas.microsoft.com/office/drawing/2014/main" val="10004"/>
+                  </a:ext>
+                </a:extLst>
               </a:tr>
               <a:tr h="301752">
                 <a:tc>
                   <a:txBody>
-                    <a:bodyPr wrap="square"/>
+                    <a:bodyPr/>
                     <a:lstStyle/>
                     <a:p>
                       <a:pPr algn="ctr"/>
@@ -14213,7 +14746,7 @@
                 </a:tc>
                 <a:tc>
                   <a:txBody>
-                    <a:bodyPr wrap="square"/>
+                    <a:bodyPr/>
                     <a:lstStyle/>
                     <a:p>
                       <a:pPr algn="ctr"/>
@@ -14235,7 +14768,7 @@
                 </a:tc>
                 <a:tc>
                   <a:txBody>
-                    <a:bodyPr wrap="square"/>
+                    <a:bodyPr/>
                     <a:lstStyle/>
                     <a:p>
                       <a:pPr algn="ctr"/>
@@ -14257,7 +14790,7 @@
                 </a:tc>
                 <a:tc>
                   <a:txBody>
-                    <a:bodyPr wrap="square"/>
+                    <a:bodyPr/>
                     <a:lstStyle/>
                     <a:p>
                       <a:pPr algn="ctr"/>
@@ -14279,7 +14812,7 @@
                 </a:tc>
                 <a:tc>
                   <a:txBody>
-                    <a:bodyPr wrap="square"/>
+                    <a:bodyPr/>
                     <a:lstStyle/>
                     <a:p>
                       <a:pPr algn="ctr"/>
@@ -14301,7 +14834,7 @@
                 </a:tc>
                 <a:tc>
                   <a:txBody>
-                    <a:bodyPr wrap="square"/>
+                    <a:bodyPr/>
                     <a:lstStyle/>
                     <a:p>
                       <a:pPr algn="ctr"/>
@@ -14321,11 +14854,16 @@
                     </a:solidFill>
                   </a:tcPr>
                 </a:tc>
+                <a:extLst>
+                  <a:ext uri="{0D108BD9-81ED-4DB2-BD59-A6C34878D82A}">
+                    <a16:rowId xmlns:a16="http://schemas.microsoft.com/office/drawing/2014/main" val="10005"/>
+                  </a:ext>
+                </a:extLst>
               </a:tr>
               <a:tr h="301752">
                 <a:tc>
                   <a:txBody>
-                    <a:bodyPr wrap="square"/>
+                    <a:bodyPr/>
                     <a:lstStyle/>
                     <a:p>
                       <a:pPr algn="ctr"/>
@@ -14347,7 +14885,7 @@
                 </a:tc>
                 <a:tc>
                   <a:txBody>
-                    <a:bodyPr wrap="square"/>
+                    <a:bodyPr/>
                     <a:lstStyle/>
                     <a:p>
                       <a:pPr algn="ctr"/>
@@ -14369,7 +14907,7 @@
                 </a:tc>
                 <a:tc>
                   <a:txBody>
-                    <a:bodyPr wrap="square"/>
+                    <a:bodyPr/>
                     <a:lstStyle/>
                     <a:p>
                       <a:pPr algn="ctr"/>
@@ -14391,7 +14929,7 @@
                 </a:tc>
                 <a:tc>
                   <a:txBody>
-                    <a:bodyPr wrap="square"/>
+                    <a:bodyPr/>
                     <a:lstStyle/>
                     <a:p>
                       <a:pPr algn="ctr"/>
@@ -14413,7 +14951,7 @@
                 </a:tc>
                 <a:tc>
                   <a:txBody>
-                    <a:bodyPr wrap="square"/>
+                    <a:bodyPr/>
                     <a:lstStyle/>
                     <a:p>
                       <a:pPr algn="ctr"/>
@@ -14435,7 +14973,7 @@
                 </a:tc>
                 <a:tc>
                   <a:txBody>
-                    <a:bodyPr wrap="square"/>
+                    <a:bodyPr/>
                     <a:lstStyle/>
                     <a:p>
                       <a:pPr algn="ctr"/>
@@ -14455,11 +14993,16 @@
                     </a:solidFill>
                   </a:tcPr>
                 </a:tc>
+                <a:extLst>
+                  <a:ext uri="{0D108BD9-81ED-4DB2-BD59-A6C34878D82A}">
+                    <a16:rowId xmlns:a16="http://schemas.microsoft.com/office/drawing/2014/main" val="10006"/>
+                  </a:ext>
+                </a:extLst>
               </a:tr>
               <a:tr h="301752">
                 <a:tc>
                   <a:txBody>
-                    <a:bodyPr wrap="square"/>
+                    <a:bodyPr/>
                     <a:lstStyle/>
                     <a:p>
                       <a:pPr algn="ctr"/>
@@ -14481,7 +15024,7 @@
                 </a:tc>
                 <a:tc>
                   <a:txBody>
-                    <a:bodyPr wrap="square"/>
+                    <a:bodyPr/>
                     <a:lstStyle/>
                     <a:p>
                       <a:pPr algn="ctr"/>
@@ -14503,7 +15046,7 @@
                 </a:tc>
                 <a:tc>
                   <a:txBody>
-                    <a:bodyPr wrap="square"/>
+                    <a:bodyPr/>
                     <a:lstStyle/>
                     <a:p>
                       <a:pPr algn="ctr"/>
@@ -14525,7 +15068,7 @@
                 </a:tc>
                 <a:tc>
                   <a:txBody>
-                    <a:bodyPr wrap="square"/>
+                    <a:bodyPr/>
                     <a:lstStyle/>
                     <a:p>
                       <a:pPr algn="ctr"/>
@@ -14547,7 +15090,7 @@
                 </a:tc>
                 <a:tc>
                   <a:txBody>
-                    <a:bodyPr wrap="square"/>
+                    <a:bodyPr/>
                     <a:lstStyle/>
                     <a:p>
                       <a:pPr algn="ctr"/>
@@ -14569,7 +15112,7 @@
                 </a:tc>
                 <a:tc>
                   <a:txBody>
-                    <a:bodyPr wrap="square"/>
+                    <a:bodyPr/>
                     <a:lstStyle/>
                     <a:p>
                       <a:pPr algn="ctr"/>
@@ -14589,11 +15132,16 @@
                     </a:solidFill>
                   </a:tcPr>
                 </a:tc>
+                <a:extLst>
+                  <a:ext uri="{0D108BD9-81ED-4DB2-BD59-A6C34878D82A}">
+                    <a16:rowId xmlns:a16="http://schemas.microsoft.com/office/drawing/2014/main" val="10007"/>
+                  </a:ext>
+                </a:extLst>
               </a:tr>
               <a:tr h="301752">
                 <a:tc>
                   <a:txBody>
-                    <a:bodyPr wrap="square"/>
+                    <a:bodyPr/>
                     <a:lstStyle/>
                     <a:p>
                       <a:pPr algn="ctr"/>
@@ -14615,7 +15163,7 @@
                 </a:tc>
                 <a:tc>
                   <a:txBody>
-                    <a:bodyPr wrap="square"/>
+                    <a:bodyPr/>
                     <a:lstStyle/>
                     <a:p>
                       <a:pPr algn="ctr"/>
@@ -14637,7 +15185,7 @@
                 </a:tc>
                 <a:tc>
                   <a:txBody>
-                    <a:bodyPr wrap="square"/>
+                    <a:bodyPr/>
                     <a:lstStyle/>
                     <a:p>
                       <a:pPr algn="ctr"/>
@@ -14659,7 +15207,7 @@
                 </a:tc>
                 <a:tc>
                   <a:txBody>
-                    <a:bodyPr wrap="square"/>
+                    <a:bodyPr/>
                     <a:lstStyle/>
                     <a:p>
                       <a:pPr algn="ctr"/>
@@ -14681,7 +15229,7 @@
                 </a:tc>
                 <a:tc>
                   <a:txBody>
-                    <a:bodyPr wrap="square"/>
+                    <a:bodyPr/>
                     <a:lstStyle/>
                     <a:p>
                       <a:pPr algn="ctr"/>
@@ -14703,7 +15251,7 @@
                 </a:tc>
                 <a:tc>
                   <a:txBody>
-                    <a:bodyPr wrap="square"/>
+                    <a:bodyPr/>
                     <a:lstStyle/>
                     <a:p>
                       <a:pPr algn="ctr"/>
@@ -14723,11 +15271,16 @@
                     </a:solidFill>
                   </a:tcPr>
                 </a:tc>
+                <a:extLst>
+                  <a:ext uri="{0D108BD9-81ED-4DB2-BD59-A6C34878D82A}">
+                    <a16:rowId xmlns:a16="http://schemas.microsoft.com/office/drawing/2014/main" val="10008"/>
+                  </a:ext>
+                </a:extLst>
               </a:tr>
               <a:tr h="301752">
                 <a:tc>
                   <a:txBody>
-                    <a:bodyPr wrap="square"/>
+                    <a:bodyPr/>
                     <a:lstStyle/>
                     <a:p>
                       <a:pPr algn="ctr"/>
@@ -14749,7 +15302,7 @@
                 </a:tc>
                 <a:tc>
                   <a:txBody>
-                    <a:bodyPr wrap="square"/>
+                    <a:bodyPr/>
                     <a:lstStyle/>
                     <a:p>
                       <a:pPr algn="ctr"/>
@@ -14771,7 +15324,7 @@
                 </a:tc>
                 <a:tc>
                   <a:txBody>
-                    <a:bodyPr wrap="square"/>
+                    <a:bodyPr/>
                     <a:lstStyle/>
                     <a:p>
                       <a:pPr algn="ctr"/>
@@ -14793,7 +15346,7 @@
                 </a:tc>
                 <a:tc>
                   <a:txBody>
-                    <a:bodyPr wrap="square"/>
+                    <a:bodyPr/>
                     <a:lstStyle/>
                     <a:p>
                       <a:pPr algn="ctr"/>
@@ -14815,7 +15368,7 @@
                 </a:tc>
                 <a:tc>
                   <a:txBody>
-                    <a:bodyPr wrap="square"/>
+                    <a:bodyPr/>
                     <a:lstStyle/>
                     <a:p>
                       <a:pPr algn="ctr"/>
@@ -14837,7 +15390,7 @@
                 </a:tc>
                 <a:tc>
                   <a:txBody>
-                    <a:bodyPr wrap="square"/>
+                    <a:bodyPr/>
                     <a:lstStyle/>
                     <a:p>
                       <a:pPr algn="ctr"/>
@@ -14857,6 +15410,11 @@
                     </a:solidFill>
                   </a:tcPr>
                 </a:tc>
+                <a:extLst>
+                  <a:ext uri="{0D108BD9-81ED-4DB2-BD59-A6C34878D82A}">
+                    <a16:rowId xmlns:a16="http://schemas.microsoft.com/office/drawing/2014/main" val="10009"/>
+                  </a:ext>
+                </a:extLst>
               </a:tr>
             </a:tbl>
           </a:graphicData>
@@ -14936,6 +15494,7 @@
           <a:lstStyle/>
           <a:p>
             <a:pPr algn="ctr"/>
+            <a:endParaRPr/>
           </a:p>
         </p:txBody>
       </p:sp>
@@ -15047,6 +15606,7 @@
           <a:lstStyle/>
           <a:p>
             <a:pPr algn="ctr"/>
+            <a:endParaRPr/>
           </a:p>
         </p:txBody>
       </p:sp>
@@ -15158,6 +15718,7 @@
           <a:lstStyle/>
           <a:p>
             <a:pPr algn="ctr"/>
+            <a:endParaRPr/>
           </a:p>
         </p:txBody>
       </p:sp>
@@ -15269,6 +15830,7 @@
           <a:lstStyle/>
           <a:p>
             <a:pPr algn="ctr"/>
+            <a:endParaRPr/>
           </a:p>
         </p:txBody>
       </p:sp>
@@ -15349,7 +15911,7 @@
 </file>
 
 <file path=ppt/slides/slide9.xml><?xml version="1.0" encoding="utf-8"?>
-<p:sld xmlns:a="http://schemas.openxmlformats.org/drawingml/2006/main" xmlns:p="http://schemas.openxmlformats.org/presentationml/2006/main" xmlns:r="http://schemas.openxmlformats.org/officeDocument/2006/relationships">
+<p:sld xmlns:a="http://schemas.openxmlformats.org/drawingml/2006/main" xmlns:r="http://schemas.openxmlformats.org/officeDocument/2006/relationships" xmlns:p="http://schemas.openxmlformats.org/presentationml/2006/main">
   <p:cSld>
     <p:bg>
       <p:bgPr>
@@ -15365,7 +15927,14 @@
         <p:cNvGrpSpPr/>
         <p:nvPr/>
       </p:nvGrpSpPr>
-      <p:grpSpPr/>
+      <p:grpSpPr>
+        <a:xfrm>
+          <a:off x="0" y="0"/>
+          <a:ext cx="0" cy="0"/>
+          <a:chOff x="0" y="0"/>
+          <a:chExt cx="0" cy="0"/>
+        </a:xfrm>
+      </p:grpSpPr>
       <p:sp>
         <p:nvSpPr>
           <p:cNvPr id="2" name="Rectangle 1"/>
@@ -15406,6 +15975,7 @@
           <a:lstStyle/>
           <a:p>
             <a:pPr algn="ctr"/>
+            <a:endParaRPr/>
           </a:p>
         </p:txBody>
       </p:sp>
@@ -15517,6 +16087,7 @@
           <a:lstStyle/>
           <a:p>
             <a:pPr algn="ctr"/>
+            <a:endParaRPr/>
           </a:p>
         </p:txBody>
       </p:sp>
@@ -15594,6 +16165,7 @@
           <a:lstStyle/>
           <a:p>
             <a:pPr algn="ctr"/>
+            <a:endParaRPr/>
           </a:p>
         </p:txBody>
       </p:sp>
@@ -15706,6 +16278,7 @@
           <a:lstStyle/>
           <a:p>
             <a:pPr algn="ctr"/>
+            <a:endParaRPr/>
           </a:p>
         </p:txBody>
       </p:sp>
@@ -15783,6 +16356,7 @@
           <a:lstStyle/>
           <a:p>
             <a:pPr algn="ctr"/>
+            <a:endParaRPr/>
           </a:p>
         </p:txBody>
       </p:sp>
@@ -15895,6 +16469,7 @@
           <a:lstStyle/>
           <a:p>
             <a:pPr algn="ctr"/>
+            <a:endParaRPr/>
           </a:p>
         </p:txBody>
       </p:sp>
@@ -15972,6 +16547,7 @@
           <a:lstStyle/>
           <a:p>
             <a:pPr algn="ctr"/>
+            <a:endParaRPr/>
           </a:p>
         </p:txBody>
       </p:sp>
@@ -16084,6 +16660,7 @@
           <a:lstStyle/>
           <a:p>
             <a:pPr algn="ctr"/>
+            <a:endParaRPr/>
           </a:p>
         </p:txBody>
       </p:sp>
@@ -16161,6 +16738,7 @@
           <a:lstStyle/>
           <a:p>
             <a:pPr algn="ctr"/>
+            <a:endParaRPr/>
           </a:p>
         </p:txBody>
       </p:sp>
@@ -16273,6 +16851,7 @@
           <a:lstStyle/>
           <a:p>
             <a:pPr algn="ctr"/>
+            <a:endParaRPr/>
           </a:p>
         </p:txBody>
       </p:sp>
@@ -16350,6 +16929,7 @@
           <a:lstStyle/>
           <a:p>
             <a:pPr algn="ctr"/>
+            <a:endParaRPr/>
           </a:p>
         </p:txBody>
       </p:sp>
@@ -16462,6 +17042,7 @@
           <a:lstStyle/>
           <a:p>
             <a:pPr algn="ctr"/>
+            <a:endParaRPr/>
           </a:p>
         </p:txBody>
       </p:sp>

</xml_diff>